<commit_message>
update: replace presentation with finalized submission template
</commit_message>
<xml_diff>
--- a/presentation/Seasonal_Agriculture_Performance_Analysis.pptx
+++ b/presentation/Seasonal_Agriculture_Performance_Analysis.pptx
@@ -10042,50 +10042,60 @@
         </p:nvSpPr>
         <p:spPr>
           <a:xfrm>
-            <a:off x="-223157" y="3583914"/>
-            <a:ext cx="3400089" cy="861497"/>
+            <a:off x="1269741" y="3655498"/>
+            <a:ext cx="6914139" cy="861497"/>
           </a:xfrm>
         </p:spPr>
         <p:txBody>
           <a:bodyPr vert="horz" lIns="91440" tIns="45720" rIns="91440" bIns="45720" rtlCol="0" anchor="t">
-            <a:normAutofit/>
+            <a:normAutofit fontScale="85000" lnSpcReduction="20000"/>
           </a:bodyPr>
           <a:lstStyle/>
           <a:p>
-            <a:pPr>
-              <a:defRPr sz="1500">
-                <a:solidFill>
-                  <a:srgbClr val="475569"/>
-                </a:solidFill>
-              </a:defRPr>
-            </a:pPr>
             <a:r>
-              <a:t>Student Name: Raghav Paroli</a:t>
+              <a:rPr lang="en-US" b="0" dirty="0">
+                <a:solidFill>
+                  <a:schemeClr val="tx1"/>
+                </a:solidFill>
+              </a:rPr>
+              <a:t>Student Name Raghav Paroli </a:t>
             </a:r>
-          </a:p>
-          <a:p>
-            <a:pPr>
-              <a:defRPr sz="1500">
-                <a:solidFill>
-                  <a:srgbClr val="475569"/>
-                </a:solidFill>
-              </a:defRPr>
-            </a:pPr>
+            <a:endParaRPr lang="en-IN" b="0" dirty="0">
+              <a:solidFill>
+                <a:schemeClr val="tx1"/>
+              </a:solidFill>
+            </a:endParaRPr>
+          </a:p>
+          <a:p>
             <a:r>
-              <a:t>College: Dept. of Computer Science &amp; Data Analytics</a:t>
+              <a:rPr lang="en-US" b="0" dirty="0">
+                <a:solidFill>
+                  <a:schemeClr val="tx1"/>
+                </a:solidFill>
+              </a:rPr>
+              <a:t>College Name-</a:t>
             </a:r>
-          </a:p>
-          <a:p>
-            <a:pPr>
-              <a:defRPr sz="1500">
-                <a:solidFill>
-                  <a:srgbClr val="475569"/>
-                </a:solidFill>
-              </a:defRPr>
-            </a:pPr>
             <a:r>
-              <a:t>VOIS AICTE Batch 2026-2027</a:t>
+              <a:rPr lang="en-IN" dirty="0">
+                <a:solidFill>
+                  <a:schemeClr val="tx1"/>
+                </a:solidFill>
+              </a:rPr>
+              <a:t>Indraprastha Institute of Information Technology Delhi</a:t>
             </a:r>
+            <a:r>
+              <a:rPr lang="en-US" b="0" dirty="0">
+                <a:solidFill>
+                  <a:schemeClr val="tx1"/>
+                </a:solidFill>
+              </a:rPr>
+              <a:t> </a:t>
+            </a:r>
+            <a:endParaRPr lang="en-IN" b="0" dirty="0">
+              <a:solidFill>
+                <a:schemeClr val="tx1"/>
+              </a:solidFill>
+            </a:endParaRPr>
           </a:p>
         </p:txBody>
       </p:sp>
@@ -10107,38 +10117,25 @@
         </p:nvSpPr>
         <p:spPr>
           <a:xfrm>
-            <a:off x="678364" y="2844750"/>
-            <a:ext cx="4998720" cy="743448"/>
+            <a:off x="536594" y="2794001"/>
+            <a:ext cx="9176365" cy="743448"/>
           </a:xfrm>
         </p:spPr>
         <p:txBody>
           <a:bodyPr>
-            <a:normAutofit/>
+            <a:normAutofit fontScale="90000"/>
           </a:bodyPr>
           <a:lstStyle/>
           <a:p>
-            <a:pPr>
-              <a:defRPr b="1" sz="2800">
-                <a:solidFill>
-                  <a:srgbClr val="0F172A"/>
-                </a:solidFill>
-              </a:defRPr>
-            </a:pPr>
             <a:r>
-              <a:t>Project Title -</a:t>
+              <a:rPr lang="en-GB" sz="3200" dirty="0"/>
+              <a:t>Project Title – </a:t>
             </a:r>
-          </a:p>
-          <a:p>
-            <a:pPr>
-              <a:defRPr b="1" sz="2800">
-                <a:solidFill>
-                  <a:srgbClr val="0F172A"/>
-                </a:solidFill>
-              </a:defRPr>
-            </a:pPr>
             <a:r>
-              <a:t>Seasonal Agriculture Performance Analysis</a:t>
+              <a:rPr lang="en-IN" dirty="0"/>
+              <a:t>seasonal agriculture performance analysis</a:t>
             </a:r>
+            <a:endParaRPr lang="en-IN" sz="3200" u="sng" dirty="0"/>
           </a:p>
         </p:txBody>
       </p:sp>
@@ -10442,7 +10439,7 @@
         <p:spPr>
           <a:xfrm>
             <a:off x="957406" y="4576469"/>
-            <a:ext cx="3176362" cy="646331"/>
+            <a:ext cx="7104554" cy="369332"/>
           </a:xfrm>
           <a:prstGeom prst="rect">
             <a:avLst/>
@@ -10455,16 +10452,15 @@
           </a:bodyPr>
           <a:lstStyle/>
           <a:p>
-            <a:pPr>
-              <a:defRPr sz="1300" b="1">
-                <a:solidFill>
-                  <a:srgbClr val="1E3A8A"/>
-                </a:solidFill>
-              </a:defRPr>
-            </a:pPr>
             <a:r>
-              <a:t>AICTE STU ID : (its available in your offer letter)</a:t>
+              <a:rPr lang="en-US" b="1" dirty="0"/>
+              <a:t>AICTE STU ID : </a:t>
             </a:r>
+            <a:r>
+              <a:rPr lang="en-IN" b="1" dirty="0"/>
+              <a:t>STU6a2ef0d8505511781461208</a:t>
+            </a:r>
+            <a:endParaRPr lang="en-US" b="1" dirty="0"/>
           </a:p>
         </p:txBody>
       </p:sp>
@@ -11118,16 +11114,11 @@
           </a:bodyPr>
           <a:lstStyle/>
           <a:p>
-            <a:pPr>
-              <a:defRPr b="1" sz="2200">
-                <a:solidFill>
-                  <a:srgbClr val="0F172A"/>
-                </a:solidFill>
-              </a:defRPr>
-            </a:pPr>
             <a:r>
-              <a:t>RESULTS: Statistical Hypothesis Testing Summary</a:t>
+              <a:rPr lang="en-GB" dirty="0"/>
+              <a:t>RESULTS </a:t>
             </a:r>
+            <a:endParaRPr lang="en-IN" dirty="0"/>
           </a:p>
         </p:txBody>
       </p:sp>
@@ -11643,37 +11634,15 @@
           </a:p>
         </p:txBody>
       </p:sp>
-      <p:sp>
-        <p:nvSpPr>
-          <p:cNvPr id="10" name="Text Placeholder 1">
+      <p:pic>
+        <p:nvPicPr>
+          <p:cNvPr id="9" name="Picture 8" descr="fig04_seasonal_profitability_ci.png">
             <a:extLst>
               <a:ext uri="{FF2B5EF4-FFF2-40B4-BE49-F238E27FC236}">
-                <a16:creationId xmlns:a16="http://schemas.microsoft.com/office/drawing/2014/main" id="{F85C769B-425A-FE3B-E47A-3B747985DC52}"/>
+                <a16:creationId xmlns:a16="http://schemas.microsoft.com/office/drawing/2014/main" id="{5ED08169-BFAD-4A36-5567-66C078560114}"/>
               </a:ext>
             </a:extLst>
           </p:cNvPr>
-          <p:cNvSpPr>
-            <a:spLocks noGrp="1"/>
-          </p:cNvSpPr>
-          <p:nvPr>
-            <p:ph type="body" sz="quarter" idx="12"/>
-          </p:nvPr>
-        </p:nvSpPr>
-        <p:spPr>
-          <a:xfrm>
-            <a:off x="807164" y="1431693"/>
-            <a:ext cx="4275138" cy="477520"/>
-          </a:xfrm>
-        </p:spPr>
-        <p:txBody>
-          <a:bodyPr/>
-          <a:lstStyle/>
-          <a:p/>
-        </p:txBody>
-      </p:sp>
-      <p:pic>
-        <p:nvPicPr>
-          <p:cNvPr id="31" name="Picture 30" descr="fig12_statistical_tests_summary_table.png"/>
           <p:cNvPicPr>
             <a:picLocks noChangeAspect="1"/>
           </p:cNvPicPr>
@@ -11687,14 +11656,49 @@
         </p:blipFill>
         <p:spPr>
           <a:xfrm>
-            <a:off x="731520" y="1463040"/>
-            <a:ext cx="10515600" cy="4853354"/>
+            <a:off x="675957" y="1608410"/>
+            <a:ext cx="11169867" cy="3490583"/>
           </a:xfrm>
           <a:prstGeom prst="rect">
             <a:avLst/>
           </a:prstGeom>
         </p:spPr>
       </p:pic>
+      <p:sp>
+        <p:nvSpPr>
+          <p:cNvPr id="11" name="TextBox 10">
+            <a:extLst>
+              <a:ext uri="{FF2B5EF4-FFF2-40B4-BE49-F238E27FC236}">
+                <a16:creationId xmlns:a16="http://schemas.microsoft.com/office/drawing/2014/main" id="{53EDD7A8-A24A-8D43-8580-B3323C7F3F85}"/>
+              </a:ext>
+            </a:extLst>
+          </p:cNvPr>
+          <p:cNvSpPr txBox="1"/>
+          <p:nvPr/>
+        </p:nvSpPr>
+        <p:spPr>
+          <a:xfrm>
+            <a:off x="3657600" y="563330"/>
+            <a:ext cx="6696064" cy="584775"/>
+          </a:xfrm>
+          <a:prstGeom prst="rect">
+            <a:avLst/>
+          </a:prstGeom>
+          <a:noFill/>
+        </p:spPr>
+        <p:txBody>
+          <a:bodyPr wrap="none" rtlCol="0">
+            <a:spAutoFit/>
+          </a:bodyPr>
+          <a:lstStyle/>
+          <a:p>
+            <a:r>
+              <a:rPr lang="en-IN" sz="3200" dirty="0"/>
+              <a:t>Seasonal Field and Farm Portability</a:t>
+            </a:r>
+          </a:p>
+        </p:txBody>
+      </p:sp>
     </p:spTree>
     <p:extLst>
       <p:ext uri="{BB962C8B-B14F-4D97-AF65-F5344CB8AC3E}">
@@ -12020,121 +12024,6 @@
                       </p:childTnLst>
                     </p:cTn>
                   </p:par>
-                  <p:par>
-                    <p:cTn id="24" fill="hold">
-                      <p:stCondLst>
-                        <p:cond delay="indefinite"/>
-                      </p:stCondLst>
-                      <p:childTnLst>
-                        <p:par>
-                          <p:cTn id="25" fill="hold">
-                            <p:stCondLst>
-                              <p:cond delay="0"/>
-                            </p:stCondLst>
-                            <p:childTnLst>
-                              <p:par>
-                                <p:cTn id="26" presetID="42" presetClass="entr" presetSubtype="0" fill="hold" grpId="0" nodeType="clickEffect">
-                                  <p:stCondLst>
-                                    <p:cond delay="0"/>
-                                  </p:stCondLst>
-                                  <p:childTnLst>
-                                    <p:set>
-                                      <p:cBhvr>
-                                        <p:cTn id="27" dur="1" fill="hold">
-                                          <p:stCondLst>
-                                            <p:cond delay="0"/>
-                                          </p:stCondLst>
-                                        </p:cTn>
-                                        <p:tgtEl>
-                                          <p:spTgt spid="10">
-                                            <p:txEl>
-                                              <p:pRg st="0" end="0"/>
-                                            </p:txEl>
-                                          </p:spTgt>
-                                        </p:tgtEl>
-                                        <p:attrNameLst>
-                                          <p:attrName>style.visibility</p:attrName>
-                                        </p:attrNameLst>
-                                      </p:cBhvr>
-                                      <p:to>
-                                        <p:strVal val="visible"/>
-                                      </p:to>
-                                    </p:set>
-                                    <p:animEffect transition="in" filter="fade">
-                                      <p:cBhvr>
-                                        <p:cTn id="28" dur="1000"/>
-                                        <p:tgtEl>
-                                          <p:spTgt spid="10">
-                                            <p:txEl>
-                                              <p:pRg st="0" end="0"/>
-                                            </p:txEl>
-                                          </p:spTgt>
-                                        </p:tgtEl>
-                                      </p:cBhvr>
-                                    </p:animEffect>
-                                    <p:anim calcmode="lin" valueType="num">
-                                      <p:cBhvr>
-                                        <p:cTn id="29" dur="1000" fill="hold"/>
-                                        <p:tgtEl>
-                                          <p:spTgt spid="10">
-                                            <p:txEl>
-                                              <p:pRg st="0" end="0"/>
-                                            </p:txEl>
-                                          </p:spTgt>
-                                        </p:tgtEl>
-                                        <p:attrNameLst>
-                                          <p:attrName>ppt_x</p:attrName>
-                                        </p:attrNameLst>
-                                      </p:cBhvr>
-                                      <p:tavLst>
-                                        <p:tav tm="0">
-                                          <p:val>
-                                            <p:strVal val="#ppt_x"/>
-                                          </p:val>
-                                        </p:tav>
-                                        <p:tav tm="100000">
-                                          <p:val>
-                                            <p:strVal val="#ppt_x"/>
-                                          </p:val>
-                                        </p:tav>
-                                      </p:tavLst>
-                                    </p:anim>
-                                    <p:anim calcmode="lin" valueType="num">
-                                      <p:cBhvr>
-                                        <p:cTn id="30" dur="1000" fill="hold"/>
-                                        <p:tgtEl>
-                                          <p:spTgt spid="10">
-                                            <p:txEl>
-                                              <p:pRg st="0" end="0"/>
-                                            </p:txEl>
-                                          </p:spTgt>
-                                        </p:tgtEl>
-                                        <p:attrNameLst>
-                                          <p:attrName>ppt_y</p:attrName>
-                                        </p:attrNameLst>
-                                      </p:cBhvr>
-                                      <p:tavLst>
-                                        <p:tav tm="0">
-                                          <p:val>
-                                            <p:strVal val="#ppt_y+.1"/>
-                                          </p:val>
-                                        </p:tav>
-                                        <p:tav tm="100000">
-                                          <p:val>
-                                            <p:strVal val="#ppt_y"/>
-                                          </p:val>
-                                        </p:tav>
-                                      </p:tavLst>
-                                    </p:anim>
-                                  </p:childTnLst>
-                                </p:cTn>
-                              </p:par>
-                            </p:childTnLst>
-                          </p:cTn>
-                        </p:par>
-                      </p:childTnLst>
-                    </p:cTn>
-                  </p:par>
                 </p:childTnLst>
               </p:cTn>
               <p:prevCondLst>
@@ -12160,7 +12049,6 @@
       <p:bldP spid="4" grpId="0"/>
       <p:bldP spid="7" grpId="0"/>
       <p:bldP spid="8" grpId="0"/>
-      <p:bldP spid="10" grpId="0" build="p"/>
     </p:bldLst>
   </p:timing>
 </p:sld>
@@ -12246,13 +12134,6 @@
           </a:bodyPr>
           <a:lstStyle/>
           <a:p>
-            <a:pPr>
-              <a:defRPr b="1">
-                <a:solidFill>
-                  <a:srgbClr val="0F172A"/>
-                </a:solidFill>
-              </a:defRPr>
-            </a:pPr>
             <a:r>
               <a:rPr lang="en-IN" sz="4000" dirty="0"/>
               <a:t>Future scope</a:t>
@@ -12774,14 +12655,20 @@
       </p:sp>
       <p:sp>
         <p:nvSpPr>
-          <p:cNvPr id="24" name="TextBox 23"/>
+          <p:cNvPr id="2" name="TextBox 1">
+            <a:extLst>
+              <a:ext uri="{FF2B5EF4-FFF2-40B4-BE49-F238E27FC236}">
+                <a16:creationId xmlns:a16="http://schemas.microsoft.com/office/drawing/2014/main" id="{23582B40-6A1F-54A8-8A1B-194D614CDDE3}"/>
+              </a:ext>
+            </a:extLst>
+          </p:cNvPr>
           <p:cNvSpPr txBox="1"/>
           <p:nvPr/>
         </p:nvSpPr>
         <p:spPr>
           <a:xfrm>
-            <a:off x="731520" y="1645920"/>
-            <a:ext cx="10515600" cy="4389120"/>
+            <a:off x="711358" y="1386773"/>
+            <a:ext cx="10769283" cy="3416320"/>
           </a:xfrm>
           <a:prstGeom prst="rect">
             <a:avLst/>
@@ -12789,132 +12676,100 @@
           <a:noFill/>
         </p:spPr>
         <p:txBody>
-          <a:bodyPr wrap="square">
+          <a:bodyPr wrap="square" rtlCol="0">
             <a:spAutoFit/>
           </a:bodyPr>
           <a:lstStyle/>
           <a:p>
-            <a:pPr>
-              <a:defRPr sz="1350">
-                <a:solidFill>
-                  <a:srgbClr val="475569"/>
-                </a:solidFill>
-              </a:defRPr>
-            </a:pPr>
+            <a:pPr lvl="0"/>
             <a:r>
-              <a:t>â€¢ Multi-Year Longitudinal Modeling:</a:t>
+              <a:rPr lang="en-IN" b="1" dirty="0"/>
+              <a:t>Multi-Year Longitudinal </a:t>
             </a:r>
-          </a:p>
-          <a:p>
-            <a:pPr>
-              <a:defRPr sz="1350">
-                <a:solidFill>
-                  <a:srgbClr val="475569"/>
-                </a:solidFill>
-              </a:defRPr>
-            </a:pPr>
             <a:r>
-              <a:t>  Expand the cross-sectional dataset across multi-decadal time-series to capture climate change impacts and El NiÃ±o cycles.</a:t>
+              <a:rPr lang="en-IN" b="1" dirty="0" err="1"/>
+              <a:t>Modeling</a:t>
             </a:r>
-          </a:p>
-          <a:p>
-            <a:pPr>
-              <a:defRPr sz="1350">
-                <a:solidFill>
-                  <a:srgbClr val="475569"/>
-                </a:solidFill>
-              </a:defRPr>
-            </a:pPr>
-          </a:p>
-          <a:p>
-            <a:pPr>
-              <a:defRPr sz="1350">
-                <a:solidFill>
-                  <a:srgbClr val="475569"/>
-                </a:solidFill>
-              </a:defRPr>
-            </a:pPr>
             <a:r>
-              <a:t>â€¢ Predictive Yield &amp; Revenue Machine Learning:</a:t>
+              <a:rPr lang="en-IN" b="1" dirty="0"/>
+              <a:t>:</a:t>
             </a:r>
-          </a:p>
-          <a:p>
-            <a:pPr>
-              <a:defRPr sz="1350">
-                <a:solidFill>
-                  <a:srgbClr val="475569"/>
-                </a:solidFill>
-              </a:defRPr>
-            </a:pPr>
             <a:r>
-              <a:t>  Deploy ensemble models (XGBoost, LightGBM, CatBoost) to forecast pre-sowing farm profits based on early-season meteorology.</a:t>
+              <a:rPr lang="en-IN" dirty="0"/>
+              <a:t> Expand dataset across multi-decadal time series to track long-term climate variability and monsoon shift impacts.</a:t>
             </a:r>
           </a:p>
           <a:p>
-            <a:pPr>
-              <a:defRPr sz="1350">
-                <a:solidFill>
-                  <a:srgbClr val="475569"/>
-                </a:solidFill>
-              </a:defRPr>
-            </a:pPr>
-          </a:p>
-          <a:p>
-            <a:pPr>
-              <a:defRPr sz="1350">
-                <a:solidFill>
-                  <a:srgbClr val="475569"/>
-                </a:solidFill>
-              </a:defRPr>
-            </a:pPr>
+            <a:pPr lvl="0"/>
+            <a:endParaRPr lang="en-IN" dirty="0"/>
+          </a:p>
+          <a:p>
+            <a:pPr lvl="0"/>
             <a:r>
-              <a:t>â€¢ Remote Sensing &amp; Satellite NDVI Integration:</a:t>
+              <a:rPr lang="en-IN" b="1" dirty="0"/>
+              <a:t>Predictive Machine Learning:</a:t>
             </a:r>
-          </a:p>
-          <a:p>
-            <a:pPr>
-              <a:defRPr sz="1350">
-                <a:solidFill>
-                  <a:srgbClr val="475569"/>
-                </a:solidFill>
-              </a:defRPr>
-            </a:pPr>
             <a:r>
-              <a:t>  Incorporate Sentinel-2 and Landsat multispectral imagery to validate soil moisture, crop canopy vigor, and field stress remotely.</a:t>
+              <a:rPr lang="en-IN" dirty="0"/>
+              <a:t> Deploy ensemble ML models (</a:t>
             </a:r>
-          </a:p>
-          <a:p>
-            <a:pPr>
-              <a:defRPr sz="1350">
-                <a:solidFill>
-                  <a:srgbClr val="475569"/>
-                </a:solidFill>
-              </a:defRPr>
-            </a:pPr>
-          </a:p>
-          <a:p>
-            <a:pPr>
-              <a:defRPr sz="1350">
-                <a:solidFill>
-                  <a:srgbClr val="475569"/>
-                </a:solidFill>
-              </a:defRPr>
-            </a:pPr>
             <a:r>
-              <a:t>â€¢ Hyper-Local IoT Agro-Advisory System:</a:t>
+              <a:rPr lang="en-IN" dirty="0" err="1"/>
+              <a:t>XGBoost</a:t>
             </a:r>
-          </a:p>
-          <a:p>
-            <a:pPr>
-              <a:defRPr sz="1350">
-                <a:solidFill>
-                  <a:srgbClr val="475569"/>
-                </a:solidFill>
-              </a:defRPr>
-            </a:pPr>
             <a:r>
-              <a:t>  Deploy low-cost farm IoT sensor nodes for micro-climatic pest alerts, dynamic irrigation scheduling, and mobile advisories.</a:t>
+              <a:rPr lang="en-IN" dirty="0"/>
+              <a:t>, </a:t>
             </a:r>
+            <a:r>
+              <a:rPr lang="en-IN" dirty="0" err="1"/>
+              <a:t>LightGBM</a:t>
+            </a:r>
+            <a:r>
+              <a:rPr lang="en-IN" dirty="0"/>
+              <a:t>) for pre-sowing yield and profit forecasting based on early seasonal forecasts.</a:t>
+            </a:r>
+          </a:p>
+          <a:p>
+            <a:pPr lvl="0"/>
+            <a:endParaRPr lang="en-IN" dirty="0"/>
+          </a:p>
+          <a:p>
+            <a:pPr lvl="0"/>
+            <a:r>
+              <a:rPr lang="en-IN" b="1" dirty="0"/>
+              <a:t>Satellite Remote Sensing (NDVI):</a:t>
+            </a:r>
+            <a:r>
+              <a:rPr lang="en-IN" dirty="0"/>
+              <a:t> Integrate Sentinel-2 and Landsat multispectral imagery to monitor vegetation health, canopy </a:t>
+            </a:r>
+            <a:r>
+              <a:rPr lang="en-IN" dirty="0" err="1"/>
+              <a:t>vigor</a:t>
+            </a:r>
+            <a:r>
+              <a:rPr lang="en-IN" dirty="0"/>
+              <a:t>, and soil moisture in real time.</a:t>
+            </a:r>
+          </a:p>
+          <a:p>
+            <a:pPr lvl="0"/>
+            <a:endParaRPr lang="en-IN" dirty="0"/>
+          </a:p>
+          <a:p>
+            <a:pPr lvl="0"/>
+            <a:r>
+              <a:rPr lang="en-IN" b="1" dirty="0"/>
+              <a:t>Hyper-Local IoT Advisory:</a:t>
+            </a:r>
+            <a:r>
+              <a:rPr lang="en-IN" dirty="0"/>
+              <a:t> Implement affordable on-field IoT sensors for automated irrigation scheduling and real-time pest alert advisories.</a:t>
+            </a:r>
+          </a:p>
+          <a:p>
+            <a:endParaRPr lang="en-IN" dirty="0"/>
           </a:p>
         </p:txBody>
       </p:sp>
@@ -13353,13 +13208,6 @@
           </a:bodyPr>
           <a:lstStyle/>
           <a:p>
-            <a:pPr>
-              <a:defRPr b="1">
-                <a:solidFill>
-                  <a:srgbClr val="0F172A"/>
-                </a:solidFill>
-              </a:defRPr>
-            </a:pPr>
             <a:r>
               <a:rPr lang="en-IN" sz="4000" dirty="0"/>
               <a:t>GitHub Link</a:t>
@@ -13893,7 +13741,7 @@
         </p:nvSpPr>
         <p:spPr>
           <a:xfrm>
-            <a:off x="729256" y="1440320"/>
+            <a:off x="729256" y="1295118"/>
             <a:ext cx="7232875" cy="646331"/>
           </a:xfrm>
           <a:prstGeom prst="rect">
@@ -13907,96 +13755,9 @@
           </a:bodyPr>
           <a:lstStyle/>
           <a:p>
-            <a:pPr>
-              <a:defRPr sz="1300">
-                <a:solidFill>
-                  <a:srgbClr val="475569"/>
-                </a:solidFill>
-              </a:defRPr>
-            </a:pPr>
             <a:r>
-              <a:t>https://github.com/raghavparoli07-art/seasonal-agriculture-performance-analysis</a:t>
-            </a:r>
-          </a:p>
-          <a:p>
-            <a:pPr>
-              <a:defRPr sz="1300">
-                <a:solidFill>
-                  <a:srgbClr val="475569"/>
-                </a:solidFill>
-              </a:defRPr>
-            </a:pPr>
-          </a:p>
-          <a:p>
-            <a:pPr>
-              <a:defRPr sz="1300">
-                <a:solidFill>
-                  <a:srgbClr val="475569"/>
-                </a:solidFill>
-              </a:defRPr>
-            </a:pPr>
-            <a:r>
-              <a:t>Repository Contents &amp; Deliverables:</a:t>
-            </a:r>
-          </a:p>
-          <a:p>
-            <a:pPr>
-              <a:defRPr sz="1300">
-                <a:solidFill>
-                  <a:srgbClr val="475569"/>
-                </a:solidFill>
-              </a:defRPr>
-            </a:pPr>
-            <a:r>
-              <a:t>â€¢ Full Executed Jupyter Notebook (47 cells, complete outputs, visualizations, markdown)</a:t>
-            </a:r>
-          </a:p>
-          <a:p>
-            <a:pPr>
-              <a:defRPr sz="1300">
-                <a:solidFill>
-                  <a:srgbClr val="475569"/>
-                </a:solidFill>
-              </a:defRPr>
-            </a:pPr>
-            <a:r>
-              <a:t>â€¢ Raw and Cleaned Processed Datasets (data/raw &amp; data/processed)</a:t>
-            </a:r>
-          </a:p>
-          <a:p>
-            <a:pPr>
-              <a:defRPr sz="1300">
-                <a:solidFill>
-                  <a:srgbClr val="475569"/>
-                </a:solidFill>
-              </a:defRPr>
-            </a:pPr>
-            <a:r>
-              <a:t>â€¢ 15 High-Resolution 300 DPI Publication-Grade Figures (outputs/figures)</a:t>
-            </a:r>
-          </a:p>
-          <a:p>
-            <a:pPr>
-              <a:defRPr sz="1300">
-                <a:solidFill>
-                  <a:srgbClr val="475569"/>
-                </a:solidFill>
-              </a:defRPr>
-            </a:pPr>
-            <a:r>
-              <a:t>â€¢ Complete 14-Slide Official PPTX Presentation Deck (presentation/)</a:t>
-            </a:r>
-          </a:p>
-          <a:p>
-            <a:pPr>
-              <a:defRPr sz="1300">
-                <a:solidFill>
-                  <a:srgbClr val="475569"/>
-                </a:solidFill>
-              </a:defRPr>
-            </a:pPr>
-            <a:r>
-              <a:t>â€¢ Comprehensive Technical README and Environment Requirements</a:t>
+              <a:rPr lang="en-US" dirty="0"/>
+              <a:t>https://github.com/raghavparoli07-art/seasonal-agriculture-performance-analysis/tree/main</a:t>
             </a:r>
           </a:p>
         </p:txBody>
@@ -14436,13 +14197,6 @@
           </a:bodyPr>
           <a:lstStyle/>
           <a:p>
-            <a:pPr>
-              <a:defRPr b="1">
-                <a:solidFill>
-                  <a:srgbClr val="0F172A"/>
-                </a:solidFill>
-              </a:defRPr>
-            </a:pPr>
             <a:r>
               <a:rPr lang="en-IN" sz="3200" dirty="0"/>
               <a:t>VOIS Course completion certificate - </a:t>
@@ -14971,7 +14725,13 @@
       </p:sp>
       <p:pic>
         <p:nvPicPr>
-          <p:cNvPr id="24" name="Picture 23" descr="vois_data_viz_certificate.png"/>
+          <p:cNvPr id="3" name="Picture 2">
+            <a:extLst>
+              <a:ext uri="{FF2B5EF4-FFF2-40B4-BE49-F238E27FC236}">
+                <a16:creationId xmlns:a16="http://schemas.microsoft.com/office/drawing/2014/main" id="{D16E6C60-E243-F62F-9AD9-0D39DAEDA382}"/>
+              </a:ext>
+            </a:extLst>
+          </p:cNvPr>
           <p:cNvPicPr>
             <a:picLocks noChangeAspect="1"/>
           </p:cNvPicPr>
@@ -14985,8 +14745,8 @@
         </p:blipFill>
         <p:spPr>
           <a:xfrm>
-            <a:off x="1645920" y="1463040"/>
-            <a:ext cx="8046720" cy="5462911"/>
+            <a:off x="2077303" y="1645493"/>
+            <a:ext cx="6950042" cy="4922947"/>
           </a:xfrm>
           <a:prstGeom prst="rect">
             <a:avLst/>
@@ -15382,37 +15142,28 @@
           </p:nvPr>
         </p:nvSpPr>
         <p:spPr>
+          <a:xfrm>
+            <a:off x="0" y="2744881"/>
+            <a:ext cx="11340000" cy="700114"/>
+          </a:xfrm>
           <a:prstGeom prst="rect">
             <a:avLst/>
           </a:prstGeom>
         </p:spPr>
         <p:txBody>
           <a:bodyPr anchor="ctr">
-            <a:normAutofit fontScale="90000"/>
+            <a:noAutofit/>
           </a:bodyPr>
           <a:lstStyle/>
           <a:p>
-            <a:pPr>
-              <a:defRPr b="1" sz="3600">
-                <a:solidFill>
-                  <a:srgbClr val="0F172A"/>
-                </a:solidFill>
-              </a:defRPr>
-            </a:pPr>
+            <a:pPr algn="ctr"/>
             <a:r>
-              <a:t>Thank You</a:t>
-            </a:r>
-          </a:p>
-          <a:p>
-            <a:pPr>
-              <a:defRPr b="1" sz="3600">
-                <a:solidFill>
-                  <a:srgbClr val="0F172A"/>
-                </a:solidFill>
-              </a:defRPr>
-            </a:pPr>
-            <a:r>
-              <a:t>Questions &amp; Discussion</a:t>
+              <a:rPr lang="en-US" sz="4800" b="1" dirty="0">
+                <a:solidFill>
+                  <a:schemeClr val="tx1"/>
+                </a:solidFill>
+              </a:rPr>
+              <a:t>Thank you</a:t>
             </a:r>
           </a:p>
         </p:txBody>
@@ -16764,97 +16515,6 @@
           </a:prstGeom>
         </p:spPr>
       </p:pic>
-      <p:sp>
-        <p:nvSpPr>
-          <p:cNvPr id="12" name="Text Placeholder 11">
-            <a:extLst>
-              <a:ext uri="{FF2B5EF4-FFF2-40B4-BE49-F238E27FC236}">
-                <a16:creationId xmlns:a16="http://schemas.microsoft.com/office/drawing/2014/main" id="{BC277FD7-925B-4C3D-A364-118403201507}"/>
-              </a:ext>
-            </a:extLst>
-          </p:cNvPr>
-          <p:cNvSpPr>
-            <a:spLocks noGrp="1"/>
-          </p:cNvSpPr>
-          <p:nvPr>
-            <p:ph type="body" sz="quarter" idx="12"/>
-          </p:nvPr>
-        </p:nvSpPr>
-        <p:spPr>
-          <a:xfrm>
-            <a:off x="2975013" y="3962573"/>
-            <a:ext cx="2139696" cy="344312"/>
-          </a:xfrm>
-        </p:spPr>
-        <p:txBody>
-          <a:bodyPr>
-            <a:normAutofit fontScale="92500" lnSpcReduction="20000"/>
-          </a:bodyPr>
-          <a:lstStyle/>
-          <a:p>
-            <a:endParaRPr lang="en-IN" dirty="0"/>
-          </a:p>
-        </p:txBody>
-      </p:sp>
-      <p:sp>
-        <p:nvSpPr>
-          <p:cNvPr id="46" name="TextBox 45"/>
-          <p:cNvSpPr txBox="1"/>
-          <p:nvPr/>
-        </p:nvSpPr>
-        <p:spPr>
-          <a:xfrm>
-            <a:off x="1371600" y="3200400"/>
-            <a:ext cx="8686800" cy="1828800"/>
-          </a:xfrm>
-          <a:prstGeom prst="rect">
-            <a:avLst/>
-          </a:prstGeom>
-          <a:noFill/>
-        </p:spPr>
-        <p:txBody>
-          <a:bodyPr wrap="square">
-            <a:spAutoFit/>
-          </a:bodyPr>
-          <a:lstStyle/>
-          <a:p>
-            <a:pPr>
-              <a:defRPr sz="1600">
-                <a:solidFill>
-                  <a:srgbClr val="475569"/>
-                </a:solidFill>
-              </a:defRPr>
-            </a:pPr>
-            <a:r>
-              <a:t>Seasonal Agriculture Performance Analysis</a:t>
-            </a:r>
-          </a:p>
-          <a:p>
-            <a:pPr>
-              <a:defRPr sz="1600">
-                <a:solidFill>
-                  <a:srgbClr val="475569"/>
-                </a:solidFill>
-              </a:defRPr>
-            </a:pPr>
-            <a:r>
-              <a:t>VOIS AICTE Batch 2026-2027 Major Project</a:t>
-            </a:r>
-          </a:p>
-          <a:p>
-            <a:pPr>
-              <a:defRPr sz="1600">
-                <a:solidFill>
-                  <a:srgbClr val="475569"/>
-                </a:solidFill>
-              </a:defRPr>
-            </a:pPr>
-            <a:r>
-              <a:t>Author: Raghav Paroli  •  GitHub: github.com/raghavparoli07-art/seasonal-agriculture-performance-analysis</a:t>
-            </a:r>
-          </a:p>
-        </p:txBody>
-      </p:sp>
     </p:spTree>
     <p:extLst>
       <p:ext uri="{BB962C8B-B14F-4D97-AF65-F5344CB8AC3E}">
@@ -17584,13 +17244,6 @@
           </a:bodyPr>
           <a:lstStyle/>
           <a:p>
-            <a:pPr>
-              <a:defRPr b="1">
-                <a:solidFill>
-                  <a:srgbClr val="0F172A"/>
-                </a:solidFill>
-              </a:defRPr>
-            </a:pPr>
             <a:r>
               <a:rPr lang="en-US" dirty="0"/>
               <a:t>PROBLEM  STATEMENT</a:t>
@@ -17974,16 +17627,24 @@
           </a:bodyPr>
           <a:lstStyle/>
           <a:p>
-            <a:pPr>
-              <a:defRPr b="1" sz="2400">
-                <a:solidFill>
-                  <a:srgbClr val="0F172A"/>
-                </a:solidFill>
-              </a:defRPr>
-            </a:pPr>
             <a:r>
+              <a:rPr lang="en-GB" dirty="0"/>
               <a:t>Project Description</a:t>
             </a:r>
+            <a:br>
+              <a:rPr lang="en-GB" dirty="0"/>
+            </a:br>
+            <a:br>
+              <a:rPr lang="en-GB" dirty="0"/>
+            </a:br>
+            <a:r>
+              <a:rPr lang="en-IN" sz="2000" b="0" dirty="0"/>
+              <a:t>This project conducts an end-to-end data science and performance analysis of 4,000 farm records across 8 Indian states, 8 major crops, and 3 agricultural seasons (Kharif, Rabi, and Zaid). The study systematically investigates how seasonal fluctuations in environmental parameters (rainfall, temperature, humidity) affect crop yield, water-use efficiency, input costs, and net farm profitability. Utilizing Python, exploratory data analysis, and rigorous hypothesis testing (ANOVA, Chi-Square, Tukey HSD), the project identifies key profitability drivers, evaluates micro-irrigation effectiveness, and delivers evidence-based recommendations to help farmers and policymakers optimize seasonal crop allocation and resource management.</a:t>
+            </a:r>
+            <a:br>
+              <a:rPr lang="en-GB" sz="2000" dirty="0"/>
+            </a:br>
+            <a:endParaRPr lang="en-IN" sz="1100" dirty="0"/>
           </a:p>
         </p:txBody>
       </p:sp>
@@ -18046,110 +17707,6 @@
           </a:prstGeom>
         </p:spPr>
       </p:pic>
-      <p:sp>
-        <p:nvSpPr>
-          <p:cNvPr id="10" name="TextBox 9"/>
-          <p:cNvSpPr txBox="1"/>
-          <p:nvPr/>
-        </p:nvSpPr>
-        <p:spPr>
-          <a:xfrm>
-            <a:off x="731520" y="1645920"/>
-            <a:ext cx="10515600" cy="4389120"/>
-          </a:xfrm>
-          <a:prstGeom prst="rect">
-            <a:avLst/>
-          </a:prstGeom>
-          <a:noFill/>
-        </p:spPr>
-        <p:txBody>
-          <a:bodyPr wrap="square">
-            <a:spAutoFit/>
-          </a:bodyPr>
-          <a:lstStyle/>
-          <a:p>
-            <a:pPr>
-              <a:defRPr sz="1350">
-                <a:solidFill>
-                  <a:srgbClr val="475569"/>
-                </a:solidFill>
-              </a:defRPr>
-            </a:pPr>
-            <a:r>
-              <a:t>This project provides an end-to-end data analytics and empirical modeling investigation into 4,000 farm-season records across 8 Indian states, 8 major crops, and 4 irrigation methods over Kharif, Rabi, and Zaid seasons.</a:t>
-            </a:r>
-          </a:p>
-          <a:p>
-            <a:pPr>
-              <a:defRPr sz="1350">
-                <a:solidFill>
-                  <a:srgbClr val="475569"/>
-                </a:solidFill>
-              </a:defRPr>
-            </a:pPr>
-          </a:p>
-          <a:p>
-            <a:pPr>
-              <a:defRPr sz="1350">
-                <a:solidFill>
-                  <a:srgbClr val="475569"/>
-                </a:solidFill>
-              </a:defRPr>
-            </a:pPr>
-            <a:r>
-              <a:t>â€¢ Data Quality &amp; Robust Imputation: Hierarchical group-wise median imputation resolves sensor gaps without collapsing genuine botanical and seasonal climatic variations.</a:t>
-            </a:r>
-          </a:p>
-          <a:p>
-            <a:pPr>
-              <a:defRPr sz="1350">
-                <a:solidFill>
-                  <a:srgbClr val="475569"/>
-                </a:solidFill>
-              </a:defRPr>
-            </a:pPr>
-            <a:r>
-              <a:t>â€¢ Comprehensive Feature Engineering: Derived domain metrics (Profit Margin %, Cost/Ha, Revenue/Ha, Fertilizer Intensity, Yield Tertiles) enable standardized multi-crop comparisons.</a:t>
-            </a:r>
-          </a:p>
-          <a:p>
-            <a:pPr>
-              <a:defRPr sz="1350">
-                <a:solidFill>
-                  <a:srgbClr val="475569"/>
-                </a:solidFill>
-              </a:defRPr>
-            </a:pPr>
-            <a:r>
-              <a:t>â€¢ Exploratory &amp; Agronomic Profiling: Investigates the 'Monsoon Penalty' paradox, sugarcane yield segmentation, and water efficiency across micro-irrigation regimes.</a:t>
-            </a:r>
-          </a:p>
-          <a:p>
-            <a:pPr>
-              <a:defRPr sz="1350">
-                <a:solidFill>
-                  <a:srgbClr val="475569"/>
-                </a:solidFill>
-              </a:defRPr>
-            </a:pPr>
-            <a:r>
-              <a:t>â€¢ Statistical Verification: Employs One-Way ANOVA, Kruskal-Wallis tests, and Tukey HSD post-hoc comparisons to establish high-confidence empirical conclusions.</a:t>
-            </a:r>
-          </a:p>
-          <a:p>
-            <a:pPr>
-              <a:defRPr sz="1350">
-                <a:solidFill>
-                  <a:srgbClr val="475569"/>
-                </a:solidFill>
-              </a:defRPr>
-            </a:pPr>
-            <a:r>
-              <a:t>â€¢ Practical Roadmap: Translates statistical findings into actionable recommendations for farmers, agricultural planners, and crop insurance policymakers.</a:t>
-            </a:r>
-          </a:p>
-        </p:txBody>
-      </p:sp>
     </p:spTree>
     <p:extLst>
       <p:ext uri="{BB962C8B-B14F-4D97-AF65-F5344CB8AC3E}">
@@ -18336,9 +17893,87 @@
         </p:spPr>
         <p:txBody>
           <a:bodyPr>
-            <a:normAutofit/>
+            <a:normAutofit fontScale="85000" lnSpcReduction="10000"/>
           </a:bodyPr>
           <a:lstStyle/>
+          <a:p>
+            <a:r>
+              <a:rPr lang="en-IN" dirty="0"/>
+              <a:t>• </a:t>
+            </a:r>
+            <a:r>
+              <a:rPr lang="en-IN" b="1" dirty="0"/>
+              <a:t>Farmers &amp; Farm Managers:</a:t>
+            </a:r>
+            <a:r>
+              <a:rPr lang="en-IN" dirty="0"/>
+              <a:t> Select optimal crops for each season, reduce excessive input costs, and adopt high-efficiency irrigation methods (Drip/Sprinkler) to maximize net profit.</a:t>
+            </a:r>
+          </a:p>
+          <a:p>
+            <a:r>
+              <a:rPr lang="en-IN" dirty="0"/>
+              <a:t>• </a:t>
+            </a:r>
+            <a:r>
+              <a:rPr lang="en-IN" b="1" dirty="0"/>
+              <a:t>Agricultural Extension Officers &amp; Agronomists:</a:t>
+            </a:r>
+            <a:r>
+              <a:rPr lang="en-IN" dirty="0"/>
+              <a:t> Deliver timely, data-driven seasonal advisories on pest/disease outbreaks, nutrient management, and water conservation.</a:t>
+            </a:r>
+          </a:p>
+          <a:p>
+            <a:r>
+              <a:rPr lang="en-IN" dirty="0"/>
+              <a:t>• </a:t>
+            </a:r>
+            <a:r>
+              <a:rPr lang="en-IN" b="1" dirty="0"/>
+              <a:t>Government Policymakers &amp; Departments of Agriculture:</a:t>
+            </a:r>
+            <a:r>
+              <a:rPr lang="en-IN" dirty="0"/>
+              <a:t> Plan seasonal resource allocation, design targeted micro-irrigation subsidies, and establish climate-resilient farming schemes.</a:t>
+            </a:r>
+          </a:p>
+          <a:p>
+            <a:r>
+              <a:rPr lang="en-IN" dirty="0"/>
+              <a:t>• </a:t>
+            </a:r>
+            <a:r>
+              <a:rPr lang="en-IN" b="1" dirty="0"/>
+              <a:t>Agri-Fintech &amp; Crop Insurance Companies:</a:t>
+            </a:r>
+            <a:r>
+              <a:rPr lang="en-IN" dirty="0"/>
+              <a:t> Evaluate seasonal risk patterns (monsoon pest risks, rainfall variability), price crop insurance accurately, and assess farm creditworthiness.</a:t>
+            </a:r>
+          </a:p>
+          <a:p>
+            <a:r>
+              <a:rPr lang="en-IN" dirty="0"/>
+              <a:t>• </a:t>
+            </a:r>
+            <a:r>
+              <a:rPr lang="en-IN" b="1" dirty="0"/>
+              <a:t>Agricultural Input Suppliers:</a:t>
+            </a:r>
+            <a:r>
+              <a:rPr lang="en-IN" dirty="0"/>
+              <a:t> Forecast seasonal demand for fertilizers, pesticides, and seeds across different states and </a:t>
+            </a:r>
+            <a:r>
+              <a:rPr lang="en-IN" dirty="0" err="1"/>
+              <a:t>agro</a:t>
+            </a:r>
+            <a:r>
+              <a:rPr lang="en-IN" dirty="0"/>
+              <a:t>-climatic zones.</a:t>
+            </a:r>
+          </a:p>
           <a:p>
             <a:pPr algn="just">
               <a:lnSpc>
@@ -18377,13 +18012,6 @@
           </a:bodyPr>
           <a:lstStyle/>
           <a:p>
-            <a:pPr>
-              <a:defRPr b="1">
-                <a:solidFill>
-                  <a:srgbClr val="0F172A"/>
-                </a:solidFill>
-              </a:defRPr>
-            </a:pPr>
             <a:r>
               <a:rPr lang="en-US" sz="3200" dirty="0"/>
               <a:t>WHO ARE THE END USERS?</a:t>
@@ -18422,218 +18050,6 @@
           </a:prstGeom>
         </p:spPr>
       </p:pic>
-      <p:sp>
-        <p:nvSpPr>
-          <p:cNvPr id="17" name="TextBox 16"/>
-          <p:cNvSpPr txBox="1"/>
-          <p:nvPr/>
-        </p:nvSpPr>
-        <p:spPr>
-          <a:xfrm>
-            <a:off x="731520" y="1645920"/>
-            <a:ext cx="10515600" cy="4389120"/>
-          </a:xfrm>
-          <a:prstGeom prst="rect">
-            <a:avLst/>
-          </a:prstGeom>
-          <a:noFill/>
-        </p:spPr>
-        <p:txBody>
-          <a:bodyPr wrap="square">
-            <a:spAutoFit/>
-          </a:bodyPr>
-          <a:lstStyle/>
-          <a:p>
-            <a:pPr>
-              <a:defRPr sz="1300">
-                <a:solidFill>
-                  <a:srgbClr val="475569"/>
-                </a:solidFill>
-              </a:defRPr>
-            </a:pPr>
-            <a:r>
-              <a:t>1. Farmers &amp; Cultivators:</a:t>
-            </a:r>
-          </a:p>
-          <a:p>
-            <a:pPr>
-              <a:defRPr sz="1300">
-                <a:solidFill>
-                  <a:srgbClr val="475569"/>
-                </a:solidFill>
-              </a:defRPr>
-            </a:pPr>
-            <a:r>
-              <a:t>   Select optimal seasonal crop-mix, transition from flood to micro-irrigation, and preempt Kharif pest surges.</a:t>
-            </a:r>
-          </a:p>
-          <a:p>
-            <a:pPr>
-              <a:defRPr sz="1300">
-                <a:solidFill>
-                  <a:srgbClr val="475569"/>
-                </a:solidFill>
-              </a:defRPr>
-            </a:pPr>
-          </a:p>
-          <a:p>
-            <a:pPr>
-              <a:defRPr sz="1300">
-                <a:solidFill>
-                  <a:srgbClr val="475569"/>
-                </a:solidFill>
-              </a:defRPr>
-            </a:pPr>
-            <a:r>
-              <a:t>2. Agricultural Extension Officers &amp; Agronomists:</a:t>
-            </a:r>
-          </a:p>
-          <a:p>
-            <a:pPr>
-              <a:defRPr sz="1300">
-                <a:solidFill>
-                  <a:srgbClr val="475569"/>
-                </a:solidFill>
-              </a:defRPr>
-            </a:pPr>
-            <a:r>
-              <a:t>   Deliver data-backed advisories on seed varieties, fertilizer intensities, and integrated pest management (IPM).</a:t>
-            </a:r>
-          </a:p>
-          <a:p>
-            <a:pPr>
-              <a:defRPr sz="1300">
-                <a:solidFill>
-                  <a:srgbClr val="475569"/>
-                </a:solidFill>
-              </a:defRPr>
-            </a:pPr>
-          </a:p>
-          <a:p>
-            <a:pPr>
-              <a:defRPr sz="1300">
-                <a:solidFill>
-                  <a:srgbClr val="475569"/>
-                </a:solidFill>
-              </a:defRPr>
-            </a:pPr>
-            <a:r>
-              <a:t>3. Government Policymakers &amp; Planners:</a:t>
-            </a:r>
-          </a:p>
-          <a:p>
-            <a:pPr>
-              <a:defRPr sz="1300">
-                <a:solidFill>
-                  <a:srgbClr val="475569"/>
-                </a:solidFill>
-              </a:defRPr>
-            </a:pPr>
-            <a:r>
-              <a:t>   Formulate season-specific Minimum Support Prices (MSP), allocate canal water quotas, and target micro-irrigation subsidies.</a:t>
-            </a:r>
-          </a:p>
-          <a:p>
-            <a:pPr>
-              <a:defRPr sz="1300">
-                <a:solidFill>
-                  <a:srgbClr val="475569"/>
-                </a:solidFill>
-              </a:defRPr>
-            </a:pPr>
-          </a:p>
-          <a:p>
-            <a:pPr>
-              <a:defRPr sz="1300">
-                <a:solidFill>
-                  <a:srgbClr val="475569"/>
-                </a:solidFill>
-              </a:defRPr>
-            </a:pPr>
-            <a:r>
-              <a:t>4. Agri-Fintech &amp; Crop Insurance Providers:</a:t>
-            </a:r>
-          </a:p>
-          <a:p>
-            <a:pPr>
-              <a:defRPr sz="1300">
-                <a:solidFill>
-                  <a:srgbClr val="475569"/>
-                </a:solidFill>
-              </a:defRPr>
-            </a:pPr>
-            <a:r>
-              <a:t>   Design dynamic actuarial risk premiums aligned with Kharif pest vulnerabilities and seasonal farm cash-flow cycles.</a:t>
-            </a:r>
-          </a:p>
-          <a:p>
-            <a:pPr>
-              <a:defRPr sz="1300">
-                <a:solidFill>
-                  <a:srgbClr val="475569"/>
-                </a:solidFill>
-              </a:defRPr>
-            </a:pPr>
-          </a:p>
-          <a:p>
-            <a:pPr>
-              <a:defRPr sz="1300">
-                <a:solidFill>
-                  <a:srgbClr val="475569"/>
-                </a:solidFill>
-              </a:defRPr>
-            </a:pPr>
-            <a:r>
-              <a:t>5. Agrochemical &amp; Farm Input Suppliers:</a:t>
-            </a:r>
-          </a:p>
-          <a:p>
-            <a:pPr>
-              <a:defRPr sz="1300">
-                <a:solidFill>
-                  <a:srgbClr val="475569"/>
-                </a:solidFill>
-              </a:defRPr>
-            </a:pPr>
-            <a:r>
-              <a:t>   Optimize seasonal supply chain inventories for NPK fertilizers, micronutrients, and crop protection chemicals.</a:t>
-            </a:r>
-          </a:p>
-          <a:p>
-            <a:pPr>
-              <a:defRPr sz="1300">
-                <a:solidFill>
-                  <a:srgbClr val="475569"/>
-                </a:solidFill>
-              </a:defRPr>
-            </a:pPr>
-          </a:p>
-          <a:p>
-            <a:pPr>
-              <a:defRPr sz="1300">
-                <a:solidFill>
-                  <a:srgbClr val="475569"/>
-                </a:solidFill>
-              </a:defRPr>
-            </a:pPr>
-            <a:r>
-              <a:t>6. Agricultural Researchers &amp; Data Scientists:</a:t>
-            </a:r>
-          </a:p>
-          <a:p>
-            <a:pPr>
-              <a:defRPr sz="1300">
-                <a:solidFill>
-                  <a:srgbClr val="475569"/>
-                </a:solidFill>
-              </a:defRPr>
-            </a:pPr>
-            <a:r>
-              <a:t>   Serve as an empirical benchmark for climate resilience research, yield forecasting models, and resource sustainability.</a:t>
-            </a:r>
-          </a:p>
-        </p:txBody>
-      </p:sp>
     </p:spTree>
     <p:extLst>
       <p:ext uri="{BB962C8B-B14F-4D97-AF65-F5344CB8AC3E}">
@@ -18764,15 +18180,10 @@
                             </p:stCondLst>
                             <p:childTnLst>
                               <p:par>
-                                <p:cTn id="12" presetID="42" presetClass="entr" presetSubtype="0" fill="hold" grpId="0" nodeType="clickEffect" nodePh="1">
+                                <p:cTn id="12" presetID="42" presetClass="entr" presetSubtype="0" fill="hold" grpId="0" nodeType="clickEffect">
                                   <p:stCondLst>
                                     <p:cond delay="0"/>
                                   </p:stCondLst>
-                                  <p:endCondLst>
-                                    <p:cond evt="begin" delay="0">
-                                      <p:tn val="12"/>
-                                    </p:cond>
-                                  </p:endCondLst>
                                   <p:childTnLst>
                                     <p:set>
                                       <p:cBhvr>
@@ -18842,6 +18253,466 @@
                                           <p:spTgt spid="2">
                                             <p:txEl>
                                               <p:pRg st="0" end="0"/>
+                                            </p:txEl>
+                                          </p:spTgt>
+                                        </p:tgtEl>
+                                        <p:attrNameLst>
+                                          <p:attrName>ppt_y</p:attrName>
+                                        </p:attrNameLst>
+                                      </p:cBhvr>
+                                      <p:tavLst>
+                                        <p:tav tm="0">
+                                          <p:val>
+                                            <p:strVal val="#ppt_y+.1"/>
+                                          </p:val>
+                                        </p:tav>
+                                        <p:tav tm="100000">
+                                          <p:val>
+                                            <p:strVal val="#ppt_y"/>
+                                          </p:val>
+                                        </p:tav>
+                                      </p:tavLst>
+                                    </p:anim>
+                                  </p:childTnLst>
+                                </p:cTn>
+                              </p:par>
+                            </p:childTnLst>
+                          </p:cTn>
+                        </p:par>
+                      </p:childTnLst>
+                    </p:cTn>
+                  </p:par>
+                  <p:par>
+                    <p:cTn id="17" fill="hold">
+                      <p:stCondLst>
+                        <p:cond delay="indefinite"/>
+                      </p:stCondLst>
+                      <p:childTnLst>
+                        <p:par>
+                          <p:cTn id="18" fill="hold">
+                            <p:stCondLst>
+                              <p:cond delay="0"/>
+                            </p:stCondLst>
+                            <p:childTnLst>
+                              <p:par>
+                                <p:cTn id="19" presetID="42" presetClass="entr" presetSubtype="0" fill="hold" grpId="0" nodeType="clickEffect">
+                                  <p:stCondLst>
+                                    <p:cond delay="0"/>
+                                  </p:stCondLst>
+                                  <p:childTnLst>
+                                    <p:set>
+                                      <p:cBhvr>
+                                        <p:cTn id="20" dur="1" fill="hold">
+                                          <p:stCondLst>
+                                            <p:cond delay="0"/>
+                                          </p:stCondLst>
+                                        </p:cTn>
+                                        <p:tgtEl>
+                                          <p:spTgt spid="2">
+                                            <p:txEl>
+                                              <p:pRg st="1" end="1"/>
+                                            </p:txEl>
+                                          </p:spTgt>
+                                        </p:tgtEl>
+                                        <p:attrNameLst>
+                                          <p:attrName>style.visibility</p:attrName>
+                                        </p:attrNameLst>
+                                      </p:cBhvr>
+                                      <p:to>
+                                        <p:strVal val="visible"/>
+                                      </p:to>
+                                    </p:set>
+                                    <p:animEffect transition="in" filter="fade">
+                                      <p:cBhvr>
+                                        <p:cTn id="21" dur="1000"/>
+                                        <p:tgtEl>
+                                          <p:spTgt spid="2">
+                                            <p:txEl>
+                                              <p:pRg st="1" end="1"/>
+                                            </p:txEl>
+                                          </p:spTgt>
+                                        </p:tgtEl>
+                                      </p:cBhvr>
+                                    </p:animEffect>
+                                    <p:anim calcmode="lin" valueType="num">
+                                      <p:cBhvr>
+                                        <p:cTn id="22" dur="1000" fill="hold"/>
+                                        <p:tgtEl>
+                                          <p:spTgt spid="2">
+                                            <p:txEl>
+                                              <p:pRg st="1" end="1"/>
+                                            </p:txEl>
+                                          </p:spTgt>
+                                        </p:tgtEl>
+                                        <p:attrNameLst>
+                                          <p:attrName>ppt_x</p:attrName>
+                                        </p:attrNameLst>
+                                      </p:cBhvr>
+                                      <p:tavLst>
+                                        <p:tav tm="0">
+                                          <p:val>
+                                            <p:strVal val="#ppt_x"/>
+                                          </p:val>
+                                        </p:tav>
+                                        <p:tav tm="100000">
+                                          <p:val>
+                                            <p:strVal val="#ppt_x"/>
+                                          </p:val>
+                                        </p:tav>
+                                      </p:tavLst>
+                                    </p:anim>
+                                    <p:anim calcmode="lin" valueType="num">
+                                      <p:cBhvr>
+                                        <p:cTn id="23" dur="1000" fill="hold"/>
+                                        <p:tgtEl>
+                                          <p:spTgt spid="2">
+                                            <p:txEl>
+                                              <p:pRg st="1" end="1"/>
+                                            </p:txEl>
+                                          </p:spTgt>
+                                        </p:tgtEl>
+                                        <p:attrNameLst>
+                                          <p:attrName>ppt_y</p:attrName>
+                                        </p:attrNameLst>
+                                      </p:cBhvr>
+                                      <p:tavLst>
+                                        <p:tav tm="0">
+                                          <p:val>
+                                            <p:strVal val="#ppt_y+.1"/>
+                                          </p:val>
+                                        </p:tav>
+                                        <p:tav tm="100000">
+                                          <p:val>
+                                            <p:strVal val="#ppt_y"/>
+                                          </p:val>
+                                        </p:tav>
+                                      </p:tavLst>
+                                    </p:anim>
+                                  </p:childTnLst>
+                                </p:cTn>
+                              </p:par>
+                            </p:childTnLst>
+                          </p:cTn>
+                        </p:par>
+                      </p:childTnLst>
+                    </p:cTn>
+                  </p:par>
+                  <p:par>
+                    <p:cTn id="24" fill="hold">
+                      <p:stCondLst>
+                        <p:cond delay="indefinite"/>
+                      </p:stCondLst>
+                      <p:childTnLst>
+                        <p:par>
+                          <p:cTn id="25" fill="hold">
+                            <p:stCondLst>
+                              <p:cond delay="0"/>
+                            </p:stCondLst>
+                            <p:childTnLst>
+                              <p:par>
+                                <p:cTn id="26" presetID="42" presetClass="entr" presetSubtype="0" fill="hold" grpId="0" nodeType="clickEffect">
+                                  <p:stCondLst>
+                                    <p:cond delay="0"/>
+                                  </p:stCondLst>
+                                  <p:childTnLst>
+                                    <p:set>
+                                      <p:cBhvr>
+                                        <p:cTn id="27" dur="1" fill="hold">
+                                          <p:stCondLst>
+                                            <p:cond delay="0"/>
+                                          </p:stCondLst>
+                                        </p:cTn>
+                                        <p:tgtEl>
+                                          <p:spTgt spid="2">
+                                            <p:txEl>
+                                              <p:pRg st="2" end="2"/>
+                                            </p:txEl>
+                                          </p:spTgt>
+                                        </p:tgtEl>
+                                        <p:attrNameLst>
+                                          <p:attrName>style.visibility</p:attrName>
+                                        </p:attrNameLst>
+                                      </p:cBhvr>
+                                      <p:to>
+                                        <p:strVal val="visible"/>
+                                      </p:to>
+                                    </p:set>
+                                    <p:animEffect transition="in" filter="fade">
+                                      <p:cBhvr>
+                                        <p:cTn id="28" dur="1000"/>
+                                        <p:tgtEl>
+                                          <p:spTgt spid="2">
+                                            <p:txEl>
+                                              <p:pRg st="2" end="2"/>
+                                            </p:txEl>
+                                          </p:spTgt>
+                                        </p:tgtEl>
+                                      </p:cBhvr>
+                                    </p:animEffect>
+                                    <p:anim calcmode="lin" valueType="num">
+                                      <p:cBhvr>
+                                        <p:cTn id="29" dur="1000" fill="hold"/>
+                                        <p:tgtEl>
+                                          <p:spTgt spid="2">
+                                            <p:txEl>
+                                              <p:pRg st="2" end="2"/>
+                                            </p:txEl>
+                                          </p:spTgt>
+                                        </p:tgtEl>
+                                        <p:attrNameLst>
+                                          <p:attrName>ppt_x</p:attrName>
+                                        </p:attrNameLst>
+                                      </p:cBhvr>
+                                      <p:tavLst>
+                                        <p:tav tm="0">
+                                          <p:val>
+                                            <p:strVal val="#ppt_x"/>
+                                          </p:val>
+                                        </p:tav>
+                                        <p:tav tm="100000">
+                                          <p:val>
+                                            <p:strVal val="#ppt_x"/>
+                                          </p:val>
+                                        </p:tav>
+                                      </p:tavLst>
+                                    </p:anim>
+                                    <p:anim calcmode="lin" valueType="num">
+                                      <p:cBhvr>
+                                        <p:cTn id="30" dur="1000" fill="hold"/>
+                                        <p:tgtEl>
+                                          <p:spTgt spid="2">
+                                            <p:txEl>
+                                              <p:pRg st="2" end="2"/>
+                                            </p:txEl>
+                                          </p:spTgt>
+                                        </p:tgtEl>
+                                        <p:attrNameLst>
+                                          <p:attrName>ppt_y</p:attrName>
+                                        </p:attrNameLst>
+                                      </p:cBhvr>
+                                      <p:tavLst>
+                                        <p:tav tm="0">
+                                          <p:val>
+                                            <p:strVal val="#ppt_y+.1"/>
+                                          </p:val>
+                                        </p:tav>
+                                        <p:tav tm="100000">
+                                          <p:val>
+                                            <p:strVal val="#ppt_y"/>
+                                          </p:val>
+                                        </p:tav>
+                                      </p:tavLst>
+                                    </p:anim>
+                                  </p:childTnLst>
+                                </p:cTn>
+                              </p:par>
+                            </p:childTnLst>
+                          </p:cTn>
+                        </p:par>
+                      </p:childTnLst>
+                    </p:cTn>
+                  </p:par>
+                  <p:par>
+                    <p:cTn id="31" fill="hold">
+                      <p:stCondLst>
+                        <p:cond delay="indefinite"/>
+                      </p:stCondLst>
+                      <p:childTnLst>
+                        <p:par>
+                          <p:cTn id="32" fill="hold">
+                            <p:stCondLst>
+                              <p:cond delay="0"/>
+                            </p:stCondLst>
+                            <p:childTnLst>
+                              <p:par>
+                                <p:cTn id="33" presetID="42" presetClass="entr" presetSubtype="0" fill="hold" grpId="0" nodeType="clickEffect">
+                                  <p:stCondLst>
+                                    <p:cond delay="0"/>
+                                  </p:stCondLst>
+                                  <p:childTnLst>
+                                    <p:set>
+                                      <p:cBhvr>
+                                        <p:cTn id="34" dur="1" fill="hold">
+                                          <p:stCondLst>
+                                            <p:cond delay="0"/>
+                                          </p:stCondLst>
+                                        </p:cTn>
+                                        <p:tgtEl>
+                                          <p:spTgt spid="2">
+                                            <p:txEl>
+                                              <p:pRg st="3" end="3"/>
+                                            </p:txEl>
+                                          </p:spTgt>
+                                        </p:tgtEl>
+                                        <p:attrNameLst>
+                                          <p:attrName>style.visibility</p:attrName>
+                                        </p:attrNameLst>
+                                      </p:cBhvr>
+                                      <p:to>
+                                        <p:strVal val="visible"/>
+                                      </p:to>
+                                    </p:set>
+                                    <p:animEffect transition="in" filter="fade">
+                                      <p:cBhvr>
+                                        <p:cTn id="35" dur="1000"/>
+                                        <p:tgtEl>
+                                          <p:spTgt spid="2">
+                                            <p:txEl>
+                                              <p:pRg st="3" end="3"/>
+                                            </p:txEl>
+                                          </p:spTgt>
+                                        </p:tgtEl>
+                                      </p:cBhvr>
+                                    </p:animEffect>
+                                    <p:anim calcmode="lin" valueType="num">
+                                      <p:cBhvr>
+                                        <p:cTn id="36" dur="1000" fill="hold"/>
+                                        <p:tgtEl>
+                                          <p:spTgt spid="2">
+                                            <p:txEl>
+                                              <p:pRg st="3" end="3"/>
+                                            </p:txEl>
+                                          </p:spTgt>
+                                        </p:tgtEl>
+                                        <p:attrNameLst>
+                                          <p:attrName>ppt_x</p:attrName>
+                                        </p:attrNameLst>
+                                      </p:cBhvr>
+                                      <p:tavLst>
+                                        <p:tav tm="0">
+                                          <p:val>
+                                            <p:strVal val="#ppt_x"/>
+                                          </p:val>
+                                        </p:tav>
+                                        <p:tav tm="100000">
+                                          <p:val>
+                                            <p:strVal val="#ppt_x"/>
+                                          </p:val>
+                                        </p:tav>
+                                      </p:tavLst>
+                                    </p:anim>
+                                    <p:anim calcmode="lin" valueType="num">
+                                      <p:cBhvr>
+                                        <p:cTn id="37" dur="1000" fill="hold"/>
+                                        <p:tgtEl>
+                                          <p:spTgt spid="2">
+                                            <p:txEl>
+                                              <p:pRg st="3" end="3"/>
+                                            </p:txEl>
+                                          </p:spTgt>
+                                        </p:tgtEl>
+                                        <p:attrNameLst>
+                                          <p:attrName>ppt_y</p:attrName>
+                                        </p:attrNameLst>
+                                      </p:cBhvr>
+                                      <p:tavLst>
+                                        <p:tav tm="0">
+                                          <p:val>
+                                            <p:strVal val="#ppt_y+.1"/>
+                                          </p:val>
+                                        </p:tav>
+                                        <p:tav tm="100000">
+                                          <p:val>
+                                            <p:strVal val="#ppt_y"/>
+                                          </p:val>
+                                        </p:tav>
+                                      </p:tavLst>
+                                    </p:anim>
+                                  </p:childTnLst>
+                                </p:cTn>
+                              </p:par>
+                            </p:childTnLst>
+                          </p:cTn>
+                        </p:par>
+                      </p:childTnLst>
+                    </p:cTn>
+                  </p:par>
+                  <p:par>
+                    <p:cTn id="38" fill="hold">
+                      <p:stCondLst>
+                        <p:cond delay="indefinite"/>
+                      </p:stCondLst>
+                      <p:childTnLst>
+                        <p:par>
+                          <p:cTn id="39" fill="hold">
+                            <p:stCondLst>
+                              <p:cond delay="0"/>
+                            </p:stCondLst>
+                            <p:childTnLst>
+                              <p:par>
+                                <p:cTn id="40" presetID="42" presetClass="entr" presetSubtype="0" fill="hold" grpId="0" nodeType="clickEffect">
+                                  <p:stCondLst>
+                                    <p:cond delay="0"/>
+                                  </p:stCondLst>
+                                  <p:childTnLst>
+                                    <p:set>
+                                      <p:cBhvr>
+                                        <p:cTn id="41" dur="1" fill="hold">
+                                          <p:stCondLst>
+                                            <p:cond delay="0"/>
+                                          </p:stCondLst>
+                                        </p:cTn>
+                                        <p:tgtEl>
+                                          <p:spTgt spid="2">
+                                            <p:txEl>
+                                              <p:pRg st="4" end="4"/>
+                                            </p:txEl>
+                                          </p:spTgt>
+                                        </p:tgtEl>
+                                        <p:attrNameLst>
+                                          <p:attrName>style.visibility</p:attrName>
+                                        </p:attrNameLst>
+                                      </p:cBhvr>
+                                      <p:to>
+                                        <p:strVal val="visible"/>
+                                      </p:to>
+                                    </p:set>
+                                    <p:animEffect transition="in" filter="fade">
+                                      <p:cBhvr>
+                                        <p:cTn id="42" dur="1000"/>
+                                        <p:tgtEl>
+                                          <p:spTgt spid="2">
+                                            <p:txEl>
+                                              <p:pRg st="4" end="4"/>
+                                            </p:txEl>
+                                          </p:spTgt>
+                                        </p:tgtEl>
+                                      </p:cBhvr>
+                                    </p:animEffect>
+                                    <p:anim calcmode="lin" valueType="num">
+                                      <p:cBhvr>
+                                        <p:cTn id="43" dur="1000" fill="hold"/>
+                                        <p:tgtEl>
+                                          <p:spTgt spid="2">
+                                            <p:txEl>
+                                              <p:pRg st="4" end="4"/>
+                                            </p:txEl>
+                                          </p:spTgt>
+                                        </p:tgtEl>
+                                        <p:attrNameLst>
+                                          <p:attrName>ppt_x</p:attrName>
+                                        </p:attrNameLst>
+                                      </p:cBhvr>
+                                      <p:tavLst>
+                                        <p:tav tm="0">
+                                          <p:val>
+                                            <p:strVal val="#ppt_x"/>
+                                          </p:val>
+                                        </p:tav>
+                                        <p:tav tm="100000">
+                                          <p:val>
+                                            <p:strVal val="#ppt_x"/>
+                                          </p:val>
+                                        </p:tav>
+                                      </p:tavLst>
+                                    </p:anim>
+                                    <p:anim calcmode="lin" valueType="num">
+                                      <p:cBhvr>
+                                        <p:cTn id="44" dur="1000" fill="hold"/>
+                                        <p:tgtEl>
+                                          <p:spTgt spid="2">
+                                            <p:txEl>
+                                              <p:pRg st="4" end="4"/>
                                             </p:txEl>
                                           </p:spTgt>
                                         </p:tgtEl>
@@ -19005,20 +18876,105 @@
         </p:nvSpPr>
         <p:spPr>
           <a:xfrm>
-            <a:off x="390618" y="1432560"/>
+            <a:off x="660399" y="1183985"/>
             <a:ext cx="9027702" cy="5243448"/>
           </a:xfrm>
         </p:spPr>
         <p:txBody>
-          <a:bodyPr/>
+          <a:bodyPr>
+            <a:noAutofit/>
+          </a:bodyPr>
           <a:lstStyle/>
           <a:p>
-            <a:pPr lvl="1">
+            <a:pPr lvl="0"/>
+            <a:r>
+              <a:rPr lang="en-IN" sz="1800" b="1" dirty="0"/>
+              <a:t>Python 3.12:</a:t>
+            </a:r>
+            <a:r>
+              <a:rPr lang="en-IN" sz="1800" dirty="0"/>
+              <a:t> Core programming language for end-to-end data pipeline, </a:t>
+            </a:r>
+            <a:r>
+              <a:rPr lang="en-IN" sz="1800" dirty="0" err="1"/>
+              <a:t>modeling</a:t>
+            </a:r>
+            <a:r>
+              <a:rPr lang="en-IN" sz="1800" dirty="0"/>
+              <a:t>, and automated analysis.</a:t>
+            </a:r>
+          </a:p>
+          <a:p>
+            <a:pPr lvl="0"/>
+            <a:r>
+              <a:rPr lang="en-IN" sz="1800" b="1" dirty="0"/>
+              <a:t>Pandas &amp; NumPy:</a:t>
+            </a:r>
+            <a:r>
+              <a:rPr lang="en-IN" sz="1800" dirty="0"/>
+              <a:t> Data cleaning, group-wise median imputation, and numerical transformations.</a:t>
+            </a:r>
+          </a:p>
+          <a:p>
+            <a:pPr lvl="0"/>
+            <a:r>
+              <a:rPr lang="en-IN" sz="1800" b="1" dirty="0"/>
+              <a:t>Matplotlib &amp; Seaborn:</a:t>
+            </a:r>
+            <a:r>
+              <a:rPr lang="en-IN" sz="1800" dirty="0"/>
+              <a:t> Publication-grade 300 DPI visualizations, multi-panel seasonal plots, and heatmaps.</a:t>
+            </a:r>
+          </a:p>
+          <a:p>
+            <a:pPr lvl="0"/>
+            <a:r>
+              <a:rPr lang="en-IN" sz="1800" b="1" dirty="0"/>
+              <a:t>SciPy &amp; </a:t>
+            </a:r>
+            <a:r>
+              <a:rPr lang="en-IN" sz="1800" b="1" dirty="0" err="1"/>
+              <a:t>Statsmodels</a:t>
+            </a:r>
+            <a:r>
+              <a:rPr lang="en-IN" sz="1800" b="1" dirty="0"/>
+              <a:t>:</a:t>
+            </a:r>
+            <a:r>
+              <a:rPr lang="en-IN" sz="1800" dirty="0"/>
+              <a:t> Inferential statistics — One-Way ANOVA, Kruskal-Wallis, Chi-Square, and Tukey HSD post-hoc tests.</a:t>
+            </a:r>
+          </a:p>
+          <a:p>
+            <a:pPr lvl="0"/>
+            <a:r>
+              <a:rPr lang="en-IN" sz="1800" b="1" dirty="0"/>
+              <a:t>Jupyter Notebook:</a:t>
+            </a:r>
+            <a:r>
+              <a:rPr lang="en-IN" sz="1800" dirty="0"/>
+              <a:t> Interactive computational environment for reproducible research and documentation.</a:t>
+            </a:r>
+          </a:p>
+          <a:p>
+            <a:pPr lvl="0"/>
+            <a:r>
+              <a:rPr lang="en-IN" sz="1800" b="1" dirty="0"/>
+              <a:t>Git &amp; GitHub:</a:t>
+            </a:r>
+            <a:r>
+              <a:rPr lang="en-IN" sz="1800" dirty="0"/>
+              <a:t> Version control, collaborative code management, and repository hosting.</a:t>
+            </a:r>
+          </a:p>
+          <a:p>
+            <a:pPr marL="457200" lvl="1" indent="0">
               <a:lnSpc>
                 <a:spcPct val="150000"/>
               </a:lnSpc>
+              <a:buNone/>
             </a:pPr>
-            <a:endParaRPr lang="en-IN" dirty="0"/>
+            <a:endParaRPr lang="en-IN" sz="900" dirty="0"/>
           </a:p>
         </p:txBody>
       </p:sp>
@@ -19050,177 +19006,9 @@
           </a:bodyPr>
           <a:lstStyle/>
           <a:p>
-            <a:pPr>
-              <a:defRPr b="1">
-                <a:solidFill>
-                  <a:srgbClr val="0F172A"/>
-                </a:solidFill>
-              </a:defRPr>
-            </a:pPr>
             <a:r>
               <a:rPr lang="en-US" dirty="0"/>
               <a:t>Technology Used</a:t>
-            </a:r>
-          </a:p>
-        </p:txBody>
-      </p:sp>
-      <p:sp>
-        <p:nvSpPr>
-          <p:cNvPr id="17" name="TextBox 16"/>
-          <p:cNvSpPr txBox="1"/>
-          <p:nvPr/>
-        </p:nvSpPr>
-        <p:spPr>
-          <a:xfrm>
-            <a:off x="2286000" y="1645920"/>
-            <a:ext cx="8961120" cy="4389120"/>
-          </a:xfrm>
-          <a:prstGeom prst="rect">
-            <a:avLst/>
-          </a:prstGeom>
-          <a:noFill/>
-        </p:spPr>
-        <p:txBody>
-          <a:bodyPr wrap="square">
-            <a:spAutoFit/>
-          </a:bodyPr>
-          <a:lstStyle/>
-          <a:p>
-            <a:pPr>
-              <a:defRPr sz="1300">
-                <a:solidFill>
-                  <a:srgbClr val="475569"/>
-                </a:solidFill>
-              </a:defRPr>
-            </a:pPr>
-            <a:r>
-              <a:t>â€¢ Python 3.12: Core programming language for end-to-end data pipeline, modeling, and automation.</a:t>
-            </a:r>
-          </a:p>
-          <a:p>
-            <a:pPr>
-              <a:defRPr sz="1300">
-                <a:solidFill>
-                  <a:srgbClr val="475569"/>
-                </a:solidFill>
-              </a:defRPr>
-            </a:pPr>
-          </a:p>
-          <a:p>
-            <a:pPr>
-              <a:defRPr sz="1300">
-                <a:solidFill>
-                  <a:srgbClr val="475569"/>
-                </a:solidFill>
-              </a:defRPr>
-            </a:pPr>
-            <a:r>
-              <a:t>â€¢ Jupyter Notebook: Interactive computational environment for reproducible analysis and narrative storytelling.</a:t>
-            </a:r>
-          </a:p>
-          <a:p>
-            <a:pPr>
-              <a:defRPr sz="1300">
-                <a:solidFill>
-                  <a:srgbClr val="475569"/>
-                </a:solidFill>
-              </a:defRPr>
-            </a:pPr>
-          </a:p>
-          <a:p>
-            <a:pPr>
-              <a:defRPr sz="1300">
-                <a:solidFill>
-                  <a:srgbClr val="475569"/>
-                </a:solidFill>
-              </a:defRPr>
-            </a:pPr>
-            <a:r>
-              <a:t>â€¢ Pandas &amp; NumPy: High-performance data manipulation, group-wise imputation, and numerical transformations.</a:t>
-            </a:r>
-          </a:p>
-          <a:p>
-            <a:pPr>
-              <a:defRPr sz="1300">
-                <a:solidFill>
-                  <a:srgbClr val="475569"/>
-                </a:solidFill>
-              </a:defRPr>
-            </a:pPr>
-          </a:p>
-          <a:p>
-            <a:pPr>
-              <a:defRPr sz="1300">
-                <a:solidFill>
-                  <a:srgbClr val="475569"/>
-                </a:solidFill>
-              </a:defRPr>
-            </a:pPr>
-            <a:r>
-              <a:t>â€¢ Matplotlib &amp; Seaborn: Publication-grade 300 DPI visualizations, seasonal multi-panel plots, and annotated heatmaps.</a:t>
-            </a:r>
-          </a:p>
-          <a:p>
-            <a:pPr>
-              <a:defRPr sz="1300">
-                <a:solidFill>
-                  <a:srgbClr val="475569"/>
-                </a:solidFill>
-              </a:defRPr>
-            </a:pPr>
-          </a:p>
-          <a:p>
-            <a:pPr>
-              <a:defRPr sz="1300">
-                <a:solidFill>
-                  <a:srgbClr val="475569"/>
-                </a:solidFill>
-              </a:defRPr>
-            </a:pPr>
-            <a:r>
-              <a:t>â€¢ SciPy &amp; Statsmodels: Rigorous inferential statisticsâ€”One-Way ANOVA, Kruskal-Wallis, Tukey HSD, and Chi-Square tests.</a:t>
-            </a:r>
-          </a:p>
-          <a:p>
-            <a:pPr>
-              <a:defRPr sz="1300">
-                <a:solidFill>
-                  <a:srgbClr val="475569"/>
-                </a:solidFill>
-              </a:defRPr>
-            </a:pPr>
-          </a:p>
-          <a:p>
-            <a:pPr>
-              <a:defRPr sz="1300">
-                <a:solidFill>
-                  <a:srgbClr val="475569"/>
-                </a:solidFill>
-              </a:defRPr>
-            </a:pPr>
-            <a:r>
-              <a:t>â€¢ Plotly: Dynamic interactive exploratory visualization with multi-dimensional filtering.</a:t>
-            </a:r>
-          </a:p>
-          <a:p>
-            <a:pPr>
-              <a:defRPr sz="1300">
-                <a:solidFill>
-                  <a:srgbClr val="475569"/>
-                </a:solidFill>
-              </a:defRPr>
-            </a:pPr>
-          </a:p>
-          <a:p>
-            <a:pPr>
-              <a:defRPr sz="1300">
-                <a:solidFill>
-                  <a:srgbClr val="475569"/>
-                </a:solidFill>
-              </a:defRPr>
-            </a:pPr>
-            <a:r>
-              <a:t>â€¢ Git &amp; GitHub: Professional version control, collaborative code management, and open-source project dissemination.</a:t>
             </a:r>
           </a:p>
         </p:txBody>
@@ -19355,15 +19143,10 @@
                             </p:stCondLst>
                             <p:childTnLst>
                               <p:par>
-                                <p:cTn id="12" presetID="42" presetClass="entr" presetSubtype="0" fill="hold" grpId="0" nodeType="clickEffect" nodePh="1">
+                                <p:cTn id="12" presetID="42" presetClass="entr" presetSubtype="0" fill="hold" grpId="0" nodeType="clickEffect">
                                   <p:stCondLst>
                                     <p:cond delay="0"/>
                                   </p:stCondLst>
-                                  <p:endCondLst>
-                                    <p:cond evt="begin" delay="0">
-                                      <p:tn val="12"/>
-                                    </p:cond>
-                                  </p:endCondLst>
                                   <p:childTnLst>
                                     <p:set>
                                       <p:cBhvr>
@@ -19433,6 +19216,581 @@
                                           <p:spTgt spid="7">
                                             <p:txEl>
                                               <p:pRg st="0" end="0"/>
+                                            </p:txEl>
+                                          </p:spTgt>
+                                        </p:tgtEl>
+                                        <p:attrNameLst>
+                                          <p:attrName>ppt_y</p:attrName>
+                                        </p:attrNameLst>
+                                      </p:cBhvr>
+                                      <p:tavLst>
+                                        <p:tav tm="0">
+                                          <p:val>
+                                            <p:strVal val="#ppt_y+.1"/>
+                                          </p:val>
+                                        </p:tav>
+                                        <p:tav tm="100000">
+                                          <p:val>
+                                            <p:strVal val="#ppt_y"/>
+                                          </p:val>
+                                        </p:tav>
+                                      </p:tavLst>
+                                    </p:anim>
+                                  </p:childTnLst>
+                                </p:cTn>
+                              </p:par>
+                            </p:childTnLst>
+                          </p:cTn>
+                        </p:par>
+                      </p:childTnLst>
+                    </p:cTn>
+                  </p:par>
+                  <p:par>
+                    <p:cTn id="17" fill="hold">
+                      <p:stCondLst>
+                        <p:cond delay="indefinite"/>
+                      </p:stCondLst>
+                      <p:childTnLst>
+                        <p:par>
+                          <p:cTn id="18" fill="hold">
+                            <p:stCondLst>
+                              <p:cond delay="0"/>
+                            </p:stCondLst>
+                            <p:childTnLst>
+                              <p:par>
+                                <p:cTn id="19" presetID="42" presetClass="entr" presetSubtype="0" fill="hold" grpId="0" nodeType="clickEffect">
+                                  <p:stCondLst>
+                                    <p:cond delay="0"/>
+                                  </p:stCondLst>
+                                  <p:childTnLst>
+                                    <p:set>
+                                      <p:cBhvr>
+                                        <p:cTn id="20" dur="1" fill="hold">
+                                          <p:stCondLst>
+                                            <p:cond delay="0"/>
+                                          </p:stCondLst>
+                                        </p:cTn>
+                                        <p:tgtEl>
+                                          <p:spTgt spid="7">
+                                            <p:txEl>
+                                              <p:pRg st="1" end="1"/>
+                                            </p:txEl>
+                                          </p:spTgt>
+                                        </p:tgtEl>
+                                        <p:attrNameLst>
+                                          <p:attrName>style.visibility</p:attrName>
+                                        </p:attrNameLst>
+                                      </p:cBhvr>
+                                      <p:to>
+                                        <p:strVal val="visible"/>
+                                      </p:to>
+                                    </p:set>
+                                    <p:animEffect transition="in" filter="fade">
+                                      <p:cBhvr>
+                                        <p:cTn id="21" dur="1000"/>
+                                        <p:tgtEl>
+                                          <p:spTgt spid="7">
+                                            <p:txEl>
+                                              <p:pRg st="1" end="1"/>
+                                            </p:txEl>
+                                          </p:spTgt>
+                                        </p:tgtEl>
+                                      </p:cBhvr>
+                                    </p:animEffect>
+                                    <p:anim calcmode="lin" valueType="num">
+                                      <p:cBhvr>
+                                        <p:cTn id="22" dur="1000" fill="hold"/>
+                                        <p:tgtEl>
+                                          <p:spTgt spid="7">
+                                            <p:txEl>
+                                              <p:pRg st="1" end="1"/>
+                                            </p:txEl>
+                                          </p:spTgt>
+                                        </p:tgtEl>
+                                        <p:attrNameLst>
+                                          <p:attrName>ppt_x</p:attrName>
+                                        </p:attrNameLst>
+                                      </p:cBhvr>
+                                      <p:tavLst>
+                                        <p:tav tm="0">
+                                          <p:val>
+                                            <p:strVal val="#ppt_x"/>
+                                          </p:val>
+                                        </p:tav>
+                                        <p:tav tm="100000">
+                                          <p:val>
+                                            <p:strVal val="#ppt_x"/>
+                                          </p:val>
+                                        </p:tav>
+                                      </p:tavLst>
+                                    </p:anim>
+                                    <p:anim calcmode="lin" valueType="num">
+                                      <p:cBhvr>
+                                        <p:cTn id="23" dur="1000" fill="hold"/>
+                                        <p:tgtEl>
+                                          <p:spTgt spid="7">
+                                            <p:txEl>
+                                              <p:pRg st="1" end="1"/>
+                                            </p:txEl>
+                                          </p:spTgt>
+                                        </p:tgtEl>
+                                        <p:attrNameLst>
+                                          <p:attrName>ppt_y</p:attrName>
+                                        </p:attrNameLst>
+                                      </p:cBhvr>
+                                      <p:tavLst>
+                                        <p:tav tm="0">
+                                          <p:val>
+                                            <p:strVal val="#ppt_y+.1"/>
+                                          </p:val>
+                                        </p:tav>
+                                        <p:tav tm="100000">
+                                          <p:val>
+                                            <p:strVal val="#ppt_y"/>
+                                          </p:val>
+                                        </p:tav>
+                                      </p:tavLst>
+                                    </p:anim>
+                                  </p:childTnLst>
+                                </p:cTn>
+                              </p:par>
+                            </p:childTnLst>
+                          </p:cTn>
+                        </p:par>
+                      </p:childTnLst>
+                    </p:cTn>
+                  </p:par>
+                  <p:par>
+                    <p:cTn id="24" fill="hold">
+                      <p:stCondLst>
+                        <p:cond delay="indefinite"/>
+                      </p:stCondLst>
+                      <p:childTnLst>
+                        <p:par>
+                          <p:cTn id="25" fill="hold">
+                            <p:stCondLst>
+                              <p:cond delay="0"/>
+                            </p:stCondLst>
+                            <p:childTnLst>
+                              <p:par>
+                                <p:cTn id="26" presetID="42" presetClass="entr" presetSubtype="0" fill="hold" grpId="0" nodeType="clickEffect">
+                                  <p:stCondLst>
+                                    <p:cond delay="0"/>
+                                  </p:stCondLst>
+                                  <p:childTnLst>
+                                    <p:set>
+                                      <p:cBhvr>
+                                        <p:cTn id="27" dur="1" fill="hold">
+                                          <p:stCondLst>
+                                            <p:cond delay="0"/>
+                                          </p:stCondLst>
+                                        </p:cTn>
+                                        <p:tgtEl>
+                                          <p:spTgt spid="7">
+                                            <p:txEl>
+                                              <p:pRg st="2" end="2"/>
+                                            </p:txEl>
+                                          </p:spTgt>
+                                        </p:tgtEl>
+                                        <p:attrNameLst>
+                                          <p:attrName>style.visibility</p:attrName>
+                                        </p:attrNameLst>
+                                      </p:cBhvr>
+                                      <p:to>
+                                        <p:strVal val="visible"/>
+                                      </p:to>
+                                    </p:set>
+                                    <p:animEffect transition="in" filter="fade">
+                                      <p:cBhvr>
+                                        <p:cTn id="28" dur="1000"/>
+                                        <p:tgtEl>
+                                          <p:spTgt spid="7">
+                                            <p:txEl>
+                                              <p:pRg st="2" end="2"/>
+                                            </p:txEl>
+                                          </p:spTgt>
+                                        </p:tgtEl>
+                                      </p:cBhvr>
+                                    </p:animEffect>
+                                    <p:anim calcmode="lin" valueType="num">
+                                      <p:cBhvr>
+                                        <p:cTn id="29" dur="1000" fill="hold"/>
+                                        <p:tgtEl>
+                                          <p:spTgt spid="7">
+                                            <p:txEl>
+                                              <p:pRg st="2" end="2"/>
+                                            </p:txEl>
+                                          </p:spTgt>
+                                        </p:tgtEl>
+                                        <p:attrNameLst>
+                                          <p:attrName>ppt_x</p:attrName>
+                                        </p:attrNameLst>
+                                      </p:cBhvr>
+                                      <p:tavLst>
+                                        <p:tav tm="0">
+                                          <p:val>
+                                            <p:strVal val="#ppt_x"/>
+                                          </p:val>
+                                        </p:tav>
+                                        <p:tav tm="100000">
+                                          <p:val>
+                                            <p:strVal val="#ppt_x"/>
+                                          </p:val>
+                                        </p:tav>
+                                      </p:tavLst>
+                                    </p:anim>
+                                    <p:anim calcmode="lin" valueType="num">
+                                      <p:cBhvr>
+                                        <p:cTn id="30" dur="1000" fill="hold"/>
+                                        <p:tgtEl>
+                                          <p:spTgt spid="7">
+                                            <p:txEl>
+                                              <p:pRg st="2" end="2"/>
+                                            </p:txEl>
+                                          </p:spTgt>
+                                        </p:tgtEl>
+                                        <p:attrNameLst>
+                                          <p:attrName>ppt_y</p:attrName>
+                                        </p:attrNameLst>
+                                      </p:cBhvr>
+                                      <p:tavLst>
+                                        <p:tav tm="0">
+                                          <p:val>
+                                            <p:strVal val="#ppt_y+.1"/>
+                                          </p:val>
+                                        </p:tav>
+                                        <p:tav tm="100000">
+                                          <p:val>
+                                            <p:strVal val="#ppt_y"/>
+                                          </p:val>
+                                        </p:tav>
+                                      </p:tavLst>
+                                    </p:anim>
+                                  </p:childTnLst>
+                                </p:cTn>
+                              </p:par>
+                            </p:childTnLst>
+                          </p:cTn>
+                        </p:par>
+                      </p:childTnLst>
+                    </p:cTn>
+                  </p:par>
+                  <p:par>
+                    <p:cTn id="31" fill="hold">
+                      <p:stCondLst>
+                        <p:cond delay="indefinite"/>
+                      </p:stCondLst>
+                      <p:childTnLst>
+                        <p:par>
+                          <p:cTn id="32" fill="hold">
+                            <p:stCondLst>
+                              <p:cond delay="0"/>
+                            </p:stCondLst>
+                            <p:childTnLst>
+                              <p:par>
+                                <p:cTn id="33" presetID="42" presetClass="entr" presetSubtype="0" fill="hold" grpId="0" nodeType="clickEffect">
+                                  <p:stCondLst>
+                                    <p:cond delay="0"/>
+                                  </p:stCondLst>
+                                  <p:childTnLst>
+                                    <p:set>
+                                      <p:cBhvr>
+                                        <p:cTn id="34" dur="1" fill="hold">
+                                          <p:stCondLst>
+                                            <p:cond delay="0"/>
+                                          </p:stCondLst>
+                                        </p:cTn>
+                                        <p:tgtEl>
+                                          <p:spTgt spid="7">
+                                            <p:txEl>
+                                              <p:pRg st="3" end="3"/>
+                                            </p:txEl>
+                                          </p:spTgt>
+                                        </p:tgtEl>
+                                        <p:attrNameLst>
+                                          <p:attrName>style.visibility</p:attrName>
+                                        </p:attrNameLst>
+                                      </p:cBhvr>
+                                      <p:to>
+                                        <p:strVal val="visible"/>
+                                      </p:to>
+                                    </p:set>
+                                    <p:animEffect transition="in" filter="fade">
+                                      <p:cBhvr>
+                                        <p:cTn id="35" dur="1000"/>
+                                        <p:tgtEl>
+                                          <p:spTgt spid="7">
+                                            <p:txEl>
+                                              <p:pRg st="3" end="3"/>
+                                            </p:txEl>
+                                          </p:spTgt>
+                                        </p:tgtEl>
+                                      </p:cBhvr>
+                                    </p:animEffect>
+                                    <p:anim calcmode="lin" valueType="num">
+                                      <p:cBhvr>
+                                        <p:cTn id="36" dur="1000" fill="hold"/>
+                                        <p:tgtEl>
+                                          <p:spTgt spid="7">
+                                            <p:txEl>
+                                              <p:pRg st="3" end="3"/>
+                                            </p:txEl>
+                                          </p:spTgt>
+                                        </p:tgtEl>
+                                        <p:attrNameLst>
+                                          <p:attrName>ppt_x</p:attrName>
+                                        </p:attrNameLst>
+                                      </p:cBhvr>
+                                      <p:tavLst>
+                                        <p:tav tm="0">
+                                          <p:val>
+                                            <p:strVal val="#ppt_x"/>
+                                          </p:val>
+                                        </p:tav>
+                                        <p:tav tm="100000">
+                                          <p:val>
+                                            <p:strVal val="#ppt_x"/>
+                                          </p:val>
+                                        </p:tav>
+                                      </p:tavLst>
+                                    </p:anim>
+                                    <p:anim calcmode="lin" valueType="num">
+                                      <p:cBhvr>
+                                        <p:cTn id="37" dur="1000" fill="hold"/>
+                                        <p:tgtEl>
+                                          <p:spTgt spid="7">
+                                            <p:txEl>
+                                              <p:pRg st="3" end="3"/>
+                                            </p:txEl>
+                                          </p:spTgt>
+                                        </p:tgtEl>
+                                        <p:attrNameLst>
+                                          <p:attrName>ppt_y</p:attrName>
+                                        </p:attrNameLst>
+                                      </p:cBhvr>
+                                      <p:tavLst>
+                                        <p:tav tm="0">
+                                          <p:val>
+                                            <p:strVal val="#ppt_y+.1"/>
+                                          </p:val>
+                                        </p:tav>
+                                        <p:tav tm="100000">
+                                          <p:val>
+                                            <p:strVal val="#ppt_y"/>
+                                          </p:val>
+                                        </p:tav>
+                                      </p:tavLst>
+                                    </p:anim>
+                                  </p:childTnLst>
+                                </p:cTn>
+                              </p:par>
+                            </p:childTnLst>
+                          </p:cTn>
+                        </p:par>
+                      </p:childTnLst>
+                    </p:cTn>
+                  </p:par>
+                  <p:par>
+                    <p:cTn id="38" fill="hold">
+                      <p:stCondLst>
+                        <p:cond delay="indefinite"/>
+                      </p:stCondLst>
+                      <p:childTnLst>
+                        <p:par>
+                          <p:cTn id="39" fill="hold">
+                            <p:stCondLst>
+                              <p:cond delay="0"/>
+                            </p:stCondLst>
+                            <p:childTnLst>
+                              <p:par>
+                                <p:cTn id="40" presetID="42" presetClass="entr" presetSubtype="0" fill="hold" grpId="0" nodeType="clickEffect">
+                                  <p:stCondLst>
+                                    <p:cond delay="0"/>
+                                  </p:stCondLst>
+                                  <p:childTnLst>
+                                    <p:set>
+                                      <p:cBhvr>
+                                        <p:cTn id="41" dur="1" fill="hold">
+                                          <p:stCondLst>
+                                            <p:cond delay="0"/>
+                                          </p:stCondLst>
+                                        </p:cTn>
+                                        <p:tgtEl>
+                                          <p:spTgt spid="7">
+                                            <p:txEl>
+                                              <p:pRg st="4" end="4"/>
+                                            </p:txEl>
+                                          </p:spTgt>
+                                        </p:tgtEl>
+                                        <p:attrNameLst>
+                                          <p:attrName>style.visibility</p:attrName>
+                                        </p:attrNameLst>
+                                      </p:cBhvr>
+                                      <p:to>
+                                        <p:strVal val="visible"/>
+                                      </p:to>
+                                    </p:set>
+                                    <p:animEffect transition="in" filter="fade">
+                                      <p:cBhvr>
+                                        <p:cTn id="42" dur="1000"/>
+                                        <p:tgtEl>
+                                          <p:spTgt spid="7">
+                                            <p:txEl>
+                                              <p:pRg st="4" end="4"/>
+                                            </p:txEl>
+                                          </p:spTgt>
+                                        </p:tgtEl>
+                                      </p:cBhvr>
+                                    </p:animEffect>
+                                    <p:anim calcmode="lin" valueType="num">
+                                      <p:cBhvr>
+                                        <p:cTn id="43" dur="1000" fill="hold"/>
+                                        <p:tgtEl>
+                                          <p:spTgt spid="7">
+                                            <p:txEl>
+                                              <p:pRg st="4" end="4"/>
+                                            </p:txEl>
+                                          </p:spTgt>
+                                        </p:tgtEl>
+                                        <p:attrNameLst>
+                                          <p:attrName>ppt_x</p:attrName>
+                                        </p:attrNameLst>
+                                      </p:cBhvr>
+                                      <p:tavLst>
+                                        <p:tav tm="0">
+                                          <p:val>
+                                            <p:strVal val="#ppt_x"/>
+                                          </p:val>
+                                        </p:tav>
+                                        <p:tav tm="100000">
+                                          <p:val>
+                                            <p:strVal val="#ppt_x"/>
+                                          </p:val>
+                                        </p:tav>
+                                      </p:tavLst>
+                                    </p:anim>
+                                    <p:anim calcmode="lin" valueType="num">
+                                      <p:cBhvr>
+                                        <p:cTn id="44" dur="1000" fill="hold"/>
+                                        <p:tgtEl>
+                                          <p:spTgt spid="7">
+                                            <p:txEl>
+                                              <p:pRg st="4" end="4"/>
+                                            </p:txEl>
+                                          </p:spTgt>
+                                        </p:tgtEl>
+                                        <p:attrNameLst>
+                                          <p:attrName>ppt_y</p:attrName>
+                                        </p:attrNameLst>
+                                      </p:cBhvr>
+                                      <p:tavLst>
+                                        <p:tav tm="0">
+                                          <p:val>
+                                            <p:strVal val="#ppt_y+.1"/>
+                                          </p:val>
+                                        </p:tav>
+                                        <p:tav tm="100000">
+                                          <p:val>
+                                            <p:strVal val="#ppt_y"/>
+                                          </p:val>
+                                        </p:tav>
+                                      </p:tavLst>
+                                    </p:anim>
+                                  </p:childTnLst>
+                                </p:cTn>
+                              </p:par>
+                            </p:childTnLst>
+                          </p:cTn>
+                        </p:par>
+                      </p:childTnLst>
+                    </p:cTn>
+                  </p:par>
+                  <p:par>
+                    <p:cTn id="45" fill="hold">
+                      <p:stCondLst>
+                        <p:cond delay="indefinite"/>
+                      </p:stCondLst>
+                      <p:childTnLst>
+                        <p:par>
+                          <p:cTn id="46" fill="hold">
+                            <p:stCondLst>
+                              <p:cond delay="0"/>
+                            </p:stCondLst>
+                            <p:childTnLst>
+                              <p:par>
+                                <p:cTn id="47" presetID="42" presetClass="entr" presetSubtype="0" fill="hold" grpId="0" nodeType="clickEffect">
+                                  <p:stCondLst>
+                                    <p:cond delay="0"/>
+                                  </p:stCondLst>
+                                  <p:childTnLst>
+                                    <p:set>
+                                      <p:cBhvr>
+                                        <p:cTn id="48" dur="1" fill="hold">
+                                          <p:stCondLst>
+                                            <p:cond delay="0"/>
+                                          </p:stCondLst>
+                                        </p:cTn>
+                                        <p:tgtEl>
+                                          <p:spTgt spid="7">
+                                            <p:txEl>
+                                              <p:pRg st="5" end="5"/>
+                                            </p:txEl>
+                                          </p:spTgt>
+                                        </p:tgtEl>
+                                        <p:attrNameLst>
+                                          <p:attrName>style.visibility</p:attrName>
+                                        </p:attrNameLst>
+                                      </p:cBhvr>
+                                      <p:to>
+                                        <p:strVal val="visible"/>
+                                      </p:to>
+                                    </p:set>
+                                    <p:animEffect transition="in" filter="fade">
+                                      <p:cBhvr>
+                                        <p:cTn id="49" dur="1000"/>
+                                        <p:tgtEl>
+                                          <p:spTgt spid="7">
+                                            <p:txEl>
+                                              <p:pRg st="5" end="5"/>
+                                            </p:txEl>
+                                          </p:spTgt>
+                                        </p:tgtEl>
+                                      </p:cBhvr>
+                                    </p:animEffect>
+                                    <p:anim calcmode="lin" valueType="num">
+                                      <p:cBhvr>
+                                        <p:cTn id="50" dur="1000" fill="hold"/>
+                                        <p:tgtEl>
+                                          <p:spTgt spid="7">
+                                            <p:txEl>
+                                              <p:pRg st="5" end="5"/>
+                                            </p:txEl>
+                                          </p:spTgt>
+                                        </p:tgtEl>
+                                        <p:attrNameLst>
+                                          <p:attrName>ppt_x</p:attrName>
+                                        </p:attrNameLst>
+                                      </p:cBhvr>
+                                      <p:tavLst>
+                                        <p:tav tm="0">
+                                          <p:val>
+                                            <p:strVal val="#ppt_x"/>
+                                          </p:val>
+                                        </p:tav>
+                                        <p:tav tm="100000">
+                                          <p:val>
+                                            <p:strVal val="#ppt_x"/>
+                                          </p:val>
+                                        </p:tav>
+                                      </p:tavLst>
+                                    </p:anim>
+                                    <p:anim calcmode="lin" valueType="num">
+                                      <p:cBhvr>
+                                        <p:cTn id="51" dur="1000" fill="hold"/>
+                                        <p:tgtEl>
+                                          <p:spTgt spid="7">
+                                            <p:txEl>
+                                              <p:pRg st="5" end="5"/>
                                             </p:txEl>
                                           </p:spTgt>
                                         </p:tgtEl>
@@ -19565,16 +19923,11 @@
           </a:bodyPr>
           <a:lstStyle/>
           <a:p>
-            <a:pPr>
-              <a:defRPr b="1" sz="2200">
-                <a:solidFill>
-                  <a:srgbClr val="0F172A"/>
-                </a:solidFill>
-              </a:defRPr>
-            </a:pPr>
             <a:r>
-              <a:t>RESULTS: Seasonal Yield &amp; Farm Profitability Dynamics</a:t>
+              <a:rPr lang="en-GB" dirty="0"/>
+              <a:t>RESULTS </a:t>
             </a:r>
+            <a:endParaRPr lang="en-IN" dirty="0"/>
           </a:p>
         </p:txBody>
       </p:sp>
@@ -20092,7 +20445,13 @@
       </p:sp>
       <p:pic>
         <p:nvPicPr>
-          <p:cNvPr id="24" name="Picture 23" descr="fig04_seasonal_profitability_ci.png"/>
+          <p:cNvPr id="3" name="Picture 2">
+            <a:extLst>
+              <a:ext uri="{FF2B5EF4-FFF2-40B4-BE49-F238E27FC236}">
+                <a16:creationId xmlns:a16="http://schemas.microsoft.com/office/drawing/2014/main" id="{B5926AE5-C4D4-8EC6-D2E9-39167A4EF6CB}"/>
+              </a:ext>
+            </a:extLst>
+          </p:cNvPr>
           <p:cNvPicPr>
             <a:picLocks noChangeAspect="1"/>
           </p:cNvPicPr>
@@ -20106,8 +20465,8 @@
         </p:blipFill>
         <p:spPr>
           <a:xfrm>
-            <a:off x="731520" y="1554480"/>
-            <a:ext cx="6583680" cy="2057400"/>
+            <a:off x="320982" y="1086439"/>
+            <a:ext cx="5829805" cy="4496190"/>
           </a:xfrm>
           <a:prstGeom prst="rect">
             <a:avLst/>
@@ -20116,14 +20475,20 @@
       </p:pic>
       <p:sp>
         <p:nvSpPr>
-          <p:cNvPr id="25" name="TextBox 24"/>
+          <p:cNvPr id="6" name="TextBox 5">
+            <a:extLst>
+              <a:ext uri="{FF2B5EF4-FFF2-40B4-BE49-F238E27FC236}">
+                <a16:creationId xmlns:a16="http://schemas.microsoft.com/office/drawing/2014/main" id="{B800C12D-8A5A-D37F-A1E1-15C463ABC3CB}"/>
+              </a:ext>
+            </a:extLst>
+          </p:cNvPr>
           <p:cNvSpPr txBox="1"/>
           <p:nvPr/>
         </p:nvSpPr>
         <p:spPr>
           <a:xfrm>
-            <a:off x="7498079" y="1645920"/>
-            <a:ext cx="4114800" cy="4114800"/>
+            <a:off x="7102702" y="1638381"/>
+            <a:ext cx="4129178" cy="4247317"/>
           </a:xfrm>
           <a:prstGeom prst="rect">
             <a:avLst/>
@@ -20131,84 +20496,48 @@
           <a:noFill/>
         </p:spPr>
         <p:txBody>
-          <a:bodyPr wrap="square">
+          <a:bodyPr wrap="square" rtlCol="0">
             <a:spAutoFit/>
           </a:bodyPr>
           <a:lstStyle/>
           <a:p>
-            <a:pPr>
-              <a:defRPr sz="1250">
-                <a:solidFill>
-                  <a:srgbClr val="475569"/>
-                </a:solidFill>
-              </a:defRPr>
-            </a:pPr>
+            <a:pPr lvl="0"/>
             <a:r>
-              <a:t>Key Takeaways &amp; Findings:</a:t>
+              <a:rPr lang="en-IN" b="1" dirty="0"/>
+              <a:t>Commercial Crop Superiority:</a:t>
             </a:r>
-          </a:p>
-          <a:p>
-            <a:pPr>
-              <a:defRPr sz="1250">
-                <a:solidFill>
-                  <a:srgbClr val="475569"/>
-                </a:solidFill>
-              </a:defRPr>
-            </a:pPr>
-          </a:p>
-          <a:p>
-            <a:pPr>
-              <a:defRPr sz="1250">
-                <a:solidFill>
-                  <a:srgbClr val="475569"/>
-                </a:solidFill>
-              </a:defRPr>
-            </a:pPr>
             <a:r>
-              <a:t>â€¢ Zaid Outperformance: Achieves the highest average net profit (INR 232,042) and profit margin (11.5%), with 58.6% profitable farms.</a:t>
+              <a:rPr lang="en-IN" dirty="0"/>
+              <a:t> Chilli, Sugarcane, and Groundnut maintain strong positive margins across all three seasons.</a:t>
             </a:r>
           </a:p>
           <a:p>
-            <a:pPr>
-              <a:defRPr sz="1250">
-                <a:solidFill>
-                  <a:srgbClr val="475569"/>
-                </a:solidFill>
-              </a:defRPr>
-            </a:pPr>
-          </a:p>
-          <a:p>
-            <a:pPr>
-              <a:defRPr sz="1250">
-                <a:solidFill>
-                  <a:srgbClr val="475569"/>
-                </a:solidFill>
-              </a:defRPr>
-            </a:pPr>
+            <a:pPr lvl="0"/>
             <a:r>
-              <a:t>â€¢ Kharif Margin Squeeze: Generates only INR 28,323 mean profit, with 53.5% of farms operating at a financial loss due to elevated input costs.</a:t>
+              <a:rPr lang="en-IN" b="1" dirty="0"/>
+              <a:t>Monsoon Grain Vulnerability:</a:t>
             </a:r>
-          </a:p>
-          <a:p>
-            <a:pPr>
-              <a:defRPr sz="1250">
-                <a:solidFill>
-                  <a:srgbClr val="475569"/>
-                </a:solidFill>
-              </a:defRPr>
-            </a:pPr>
-          </a:p>
-          <a:p>
-            <a:pPr>
-              <a:defRPr sz="1250">
-                <a:solidFill>
-                  <a:srgbClr val="475569"/>
-                </a:solidFill>
-              </a:defRPr>
-            </a:pPr>
             <a:r>
-              <a:t>â€¢ Controlled Rabi Stability: Delivers steady profits (INR 119,548; 52.2% profitable farms), proving managed irrigation mitigates climate risks.</a:t>
+              <a:rPr lang="en-IN" dirty="0"/>
+              <a:t> Rice and Maize show compressed profit margins during Kharif due to elevated input costs and pest management overhead.</a:t>
             </a:r>
+          </a:p>
+          <a:p>
+            <a:pPr lvl="0"/>
+            <a:r>
+              <a:rPr lang="en-IN" b="1" dirty="0"/>
+              <a:t>Seasonal Specialization:</a:t>
+            </a:r>
+            <a:r>
+              <a:rPr lang="en-IN" dirty="0"/>
+              <a:t> Wheat achieves optimal profitability in Rabi (+₹134k average) versus off-season plantings.</a:t>
+            </a:r>
+          </a:p>
+          <a:p>
+            <a:br>
+              <a:rPr lang="en-IN" dirty="0"/>
+            </a:br>
+            <a:endParaRPr lang="en-IN" dirty="0"/>
           </a:p>
         </p:txBody>
       </p:sp>
@@ -20647,16 +20976,11 @@
           </a:bodyPr>
           <a:lstStyle/>
           <a:p>
-            <a:pPr>
-              <a:defRPr b="1" sz="2200">
-                <a:solidFill>
-                  <a:srgbClr val="0F172A"/>
-                </a:solidFill>
-              </a:defRPr>
-            </a:pPr>
             <a:r>
-              <a:t>RESULTS: Crop Ã— Season Profitability Matrix</a:t>
+              <a:rPr lang="en-GB" dirty="0"/>
+              <a:t>RESULTS </a:t>
             </a:r>
+            <a:endParaRPr lang="en-IN" dirty="0"/>
           </a:p>
         </p:txBody>
       </p:sp>
@@ -21172,37 +21496,15 @@
           </a:p>
         </p:txBody>
       </p:sp>
-      <p:sp>
-        <p:nvSpPr>
-          <p:cNvPr id="10" name="Text Placeholder 1">
+      <p:pic>
+        <p:nvPicPr>
+          <p:cNvPr id="3" name="Picture 2">
             <a:extLst>
               <a:ext uri="{FF2B5EF4-FFF2-40B4-BE49-F238E27FC236}">
-                <a16:creationId xmlns:a16="http://schemas.microsoft.com/office/drawing/2014/main" id="{3A64DB11-806F-1A4C-E0D5-D745D29CED50}"/>
+                <a16:creationId xmlns:a16="http://schemas.microsoft.com/office/drawing/2014/main" id="{18379413-757C-3C46-528C-B97D23EF6FA5}"/>
               </a:ext>
             </a:extLst>
           </p:cNvPr>
-          <p:cNvSpPr>
-            <a:spLocks noGrp="1"/>
-          </p:cNvSpPr>
-          <p:nvPr>
-            <p:ph type="body" sz="quarter" idx="12"/>
-          </p:nvPr>
-        </p:nvSpPr>
-        <p:spPr>
-          <a:xfrm>
-            <a:off x="807164" y="1431693"/>
-            <a:ext cx="4275138" cy="477520"/>
-          </a:xfrm>
-        </p:spPr>
-        <p:txBody>
-          <a:bodyPr/>
-          <a:lstStyle/>
-          <a:p/>
-        </p:txBody>
-      </p:sp>
-      <p:pic>
-        <p:nvPicPr>
-          <p:cNvPr id="31" name="Picture 30" descr="fig13_crop_season_profitability_heatmap.png"/>
           <p:cNvPicPr>
             <a:picLocks noChangeAspect="1"/>
           </p:cNvPicPr>
@@ -21216,8 +21518,8 @@
         </p:blipFill>
         <p:spPr>
           <a:xfrm>
-            <a:off x="731520" y="1554480"/>
-            <a:ext cx="6217920" cy="4352544"/>
+            <a:off x="962818" y="1413364"/>
+            <a:ext cx="8321761" cy="3360711"/>
           </a:xfrm>
           <a:prstGeom prst="rect">
             <a:avLst/>
@@ -21226,14 +21528,20 @@
       </p:pic>
       <p:sp>
         <p:nvSpPr>
-          <p:cNvPr id="32" name="TextBox 31"/>
+          <p:cNvPr id="11" name="TextBox 10">
+            <a:extLst>
+              <a:ext uri="{FF2B5EF4-FFF2-40B4-BE49-F238E27FC236}">
+                <a16:creationId xmlns:a16="http://schemas.microsoft.com/office/drawing/2014/main" id="{73581B03-F944-4F44-8BF8-B7B14662C298}"/>
+              </a:ext>
+            </a:extLst>
+          </p:cNvPr>
           <p:cNvSpPr txBox="1"/>
           <p:nvPr/>
         </p:nvSpPr>
         <p:spPr>
           <a:xfrm>
-            <a:off x="7132320" y="1645920"/>
-            <a:ext cx="4389120" cy="4114800"/>
+            <a:off x="256766" y="4912068"/>
+            <a:ext cx="11678468" cy="1477328"/>
           </a:xfrm>
           <a:prstGeom prst="rect">
             <a:avLst/>
@@ -21241,83 +21549,65 @@
           <a:noFill/>
         </p:spPr>
         <p:txBody>
-          <a:bodyPr wrap="square">
+          <a:bodyPr wrap="square" rtlCol="0">
             <a:spAutoFit/>
           </a:bodyPr>
           <a:lstStyle/>
           <a:p>
-            <a:pPr>
-              <a:defRPr sz="1250">
-                <a:solidFill>
-                  <a:srgbClr val="475569"/>
-                </a:solidFill>
-              </a:defRPr>
-            </a:pPr>
+            <a:pPr lvl="0"/>
             <a:r>
-              <a:t>Key Takeaways &amp; Findings:</a:t>
+              <a:rPr lang="en-IN" b="1"/>
+              <a:t>Monsoon Pest Surge:</a:t>
             </a:r>
-          </a:p>
-          <a:p>
-            <a:pPr>
-              <a:defRPr sz="1250">
-                <a:solidFill>
-                  <a:srgbClr val="475569"/>
-                </a:solidFill>
-              </a:defRPr>
-            </a:pPr>
-          </a:p>
-          <a:p>
-            <a:pPr>
-              <a:defRPr sz="1250">
-                <a:solidFill>
-                  <a:srgbClr val="475569"/>
-                </a:solidFill>
-              </a:defRPr>
-            </a:pPr>
             <a:r>
-              <a:t>â€¢ Commercial Crop Superiority: Chilli, Sugarcane, and Groundnut yield positive profits across all seasons, peaking in Rabi and Zaid.</a:t>
+              <a:rPr lang="en-IN"/>
+              <a:t> Kharif pest/disease risk averages </a:t>
             </a:r>
-          </a:p>
-          <a:p>
-            <a:pPr>
-              <a:defRPr sz="1250">
-                <a:solidFill>
-                  <a:srgbClr val="475569"/>
-                </a:solidFill>
-              </a:defRPr>
-            </a:pPr>
-          </a:p>
-          <a:p>
-            <a:pPr>
-              <a:defRPr sz="1250">
-                <a:solidFill>
-                  <a:srgbClr val="475569"/>
-                </a:solidFill>
-              </a:defRPr>
-            </a:pPr>
             <a:r>
-              <a:t>â€¢ Grain Crop Vulnerability: Rice and Maize experience negative net margins during Kharif, where high seed and pesticide costs outpace farm-gate prices.</a:t>
+              <a:rPr lang="en-IN" b="1"/>
+              <a:t>52.9%</a:t>
             </a:r>
-          </a:p>
-          <a:p>
-            <a:pPr>
-              <a:defRPr sz="1250">
-                <a:solidFill>
-                  <a:srgbClr val="475569"/>
-                </a:solidFill>
-              </a:defRPr>
-            </a:pPr>
-          </a:p>
-          <a:p>
-            <a:pPr>
-              <a:defRPr sz="1250">
-                <a:solidFill>
-                  <a:srgbClr val="475569"/>
-                </a:solidFill>
-              </a:defRPr>
-            </a:pPr>
             <a:r>
-              <a:t>â€¢ Seasonal Specialization: Wheat achieves optimal profitability in Rabi (+INR 134k) versus Kharif (-INR 46k), highlighting the critical role of temperature timing.</a:t>
+              <a:rPr lang="en-IN"/>
+              <a:t>, compared to </a:t>
+            </a:r>
+            <a:r>
+              <a:rPr lang="en-IN" b="1"/>
+              <a:t>38.9% in Rabi</a:t>
+            </a:r>
+            <a:r>
+              <a:rPr lang="en-IN"/>
+              <a:t> and </a:t>
+            </a:r>
+            <a:r>
+              <a:rPr lang="en-IN" b="1"/>
+              <a:t>36.9% in Zaid</a:t>
+            </a:r>
+            <a:r>
+              <a:rPr lang="en-IN"/>
+              <a:t>.</a:t>
+            </a:r>
+          </a:p>
+          <a:p>
+            <a:pPr lvl="0"/>
+            <a:r>
+              <a:rPr lang="en-IN" b="1"/>
+              <a:t>Statistical Proof:</a:t>
+            </a:r>
+            <a:r>
+              <a:rPr lang="en-IN"/>
+              <a:t> One-Way ANOVA proves this seasonal variation is highly significant ($F = 1049.47$, $p &lt; 10^{-300}$, $\eta^2 = 0.344$).</a:t>
+            </a:r>
+          </a:p>
+          <a:p>
+            <a:pPr lvl="0"/>
+            <a:r>
+              <a:rPr lang="en-IN" b="1"/>
+              <a:t>Moisture-Infestation Link:</a:t>
+            </a:r>
+            <a:r>
+              <a:rPr lang="en-IN"/>
+              <a:t> Persistent monsoon humidity (&gt;70%) strongly accelerates fungal and insect disease vectors.</a:t>
             </a:r>
           </a:p>
         </p:txBody>
@@ -21647,121 +21937,6 @@
                       </p:childTnLst>
                     </p:cTn>
                   </p:par>
-                  <p:par>
-                    <p:cTn id="24" fill="hold">
-                      <p:stCondLst>
-                        <p:cond delay="indefinite"/>
-                      </p:stCondLst>
-                      <p:childTnLst>
-                        <p:par>
-                          <p:cTn id="25" fill="hold">
-                            <p:stCondLst>
-                              <p:cond delay="0"/>
-                            </p:stCondLst>
-                            <p:childTnLst>
-                              <p:par>
-                                <p:cTn id="26" presetID="42" presetClass="entr" presetSubtype="0" fill="hold" grpId="0" nodeType="clickEffect">
-                                  <p:stCondLst>
-                                    <p:cond delay="0"/>
-                                  </p:stCondLst>
-                                  <p:childTnLst>
-                                    <p:set>
-                                      <p:cBhvr>
-                                        <p:cTn id="27" dur="1" fill="hold">
-                                          <p:stCondLst>
-                                            <p:cond delay="0"/>
-                                          </p:stCondLst>
-                                        </p:cTn>
-                                        <p:tgtEl>
-                                          <p:spTgt spid="10">
-                                            <p:txEl>
-                                              <p:pRg st="0" end="0"/>
-                                            </p:txEl>
-                                          </p:spTgt>
-                                        </p:tgtEl>
-                                        <p:attrNameLst>
-                                          <p:attrName>style.visibility</p:attrName>
-                                        </p:attrNameLst>
-                                      </p:cBhvr>
-                                      <p:to>
-                                        <p:strVal val="visible"/>
-                                      </p:to>
-                                    </p:set>
-                                    <p:animEffect transition="in" filter="fade">
-                                      <p:cBhvr>
-                                        <p:cTn id="28" dur="1000"/>
-                                        <p:tgtEl>
-                                          <p:spTgt spid="10">
-                                            <p:txEl>
-                                              <p:pRg st="0" end="0"/>
-                                            </p:txEl>
-                                          </p:spTgt>
-                                        </p:tgtEl>
-                                      </p:cBhvr>
-                                    </p:animEffect>
-                                    <p:anim calcmode="lin" valueType="num">
-                                      <p:cBhvr>
-                                        <p:cTn id="29" dur="1000" fill="hold"/>
-                                        <p:tgtEl>
-                                          <p:spTgt spid="10">
-                                            <p:txEl>
-                                              <p:pRg st="0" end="0"/>
-                                            </p:txEl>
-                                          </p:spTgt>
-                                        </p:tgtEl>
-                                        <p:attrNameLst>
-                                          <p:attrName>ppt_x</p:attrName>
-                                        </p:attrNameLst>
-                                      </p:cBhvr>
-                                      <p:tavLst>
-                                        <p:tav tm="0">
-                                          <p:val>
-                                            <p:strVal val="#ppt_x"/>
-                                          </p:val>
-                                        </p:tav>
-                                        <p:tav tm="100000">
-                                          <p:val>
-                                            <p:strVal val="#ppt_x"/>
-                                          </p:val>
-                                        </p:tav>
-                                      </p:tavLst>
-                                    </p:anim>
-                                    <p:anim calcmode="lin" valueType="num">
-                                      <p:cBhvr>
-                                        <p:cTn id="30" dur="1000" fill="hold"/>
-                                        <p:tgtEl>
-                                          <p:spTgt spid="10">
-                                            <p:txEl>
-                                              <p:pRg st="0" end="0"/>
-                                            </p:txEl>
-                                          </p:spTgt>
-                                        </p:tgtEl>
-                                        <p:attrNameLst>
-                                          <p:attrName>ppt_y</p:attrName>
-                                        </p:attrNameLst>
-                                      </p:cBhvr>
-                                      <p:tavLst>
-                                        <p:tav tm="0">
-                                          <p:val>
-                                            <p:strVal val="#ppt_y+.1"/>
-                                          </p:val>
-                                        </p:tav>
-                                        <p:tav tm="100000">
-                                          <p:val>
-                                            <p:strVal val="#ppt_y"/>
-                                          </p:val>
-                                        </p:tav>
-                                      </p:tavLst>
-                                    </p:anim>
-                                  </p:childTnLst>
-                                </p:cTn>
-                              </p:par>
-                            </p:childTnLst>
-                          </p:cTn>
-                        </p:par>
-                      </p:childTnLst>
-                    </p:cTn>
-                  </p:par>
                 </p:childTnLst>
               </p:cTn>
               <p:prevCondLst>
@@ -21787,7 +21962,6 @@
       <p:bldP spid="4" grpId="0"/>
       <p:bldP spid="7" grpId="0"/>
       <p:bldP spid="8" grpId="0"/>
-      <p:bldP spid="10" grpId="0" build="p"/>
     </p:bldLst>
   </p:timing>
 </p:sld>
@@ -21873,16 +22047,11 @@
           </a:bodyPr>
           <a:lstStyle/>
           <a:p>
-            <a:pPr>
-              <a:defRPr b="1" sz="2200">
-                <a:solidFill>
-                  <a:srgbClr val="0F172A"/>
-                </a:solidFill>
-              </a:defRPr>
-            </a:pPr>
             <a:r>
-              <a:t>RESULTS: Environmental Drivers &amp; Pest/Disease Vulnerability</a:t>
+              <a:rPr lang="en-GB" dirty="0"/>
+              <a:t>RESULTS </a:t>
             </a:r>
+            <a:endParaRPr lang="en-IN" dirty="0"/>
           </a:p>
         </p:txBody>
       </p:sp>
@@ -22398,37 +22567,15 @@
           </a:p>
         </p:txBody>
       </p:sp>
-      <p:sp>
-        <p:nvSpPr>
-          <p:cNvPr id="10" name="Text Placeholder 1">
+      <p:pic>
+        <p:nvPicPr>
+          <p:cNvPr id="9" name="Picture 8">
             <a:extLst>
               <a:ext uri="{FF2B5EF4-FFF2-40B4-BE49-F238E27FC236}">
-                <a16:creationId xmlns:a16="http://schemas.microsoft.com/office/drawing/2014/main" id="{B6E3B1C7-6A8B-23EE-6251-DC1067C6ADE9}"/>
+                <a16:creationId xmlns:a16="http://schemas.microsoft.com/office/drawing/2014/main" id="{BA66D92D-6397-9161-096D-B06D629BE109}"/>
               </a:ext>
             </a:extLst>
           </p:cNvPr>
-          <p:cNvSpPr>
-            <a:spLocks noGrp="1"/>
-          </p:cNvSpPr>
-          <p:nvPr>
-            <p:ph type="body" sz="quarter" idx="12"/>
-          </p:nvPr>
-        </p:nvSpPr>
-        <p:spPr>
-          <a:xfrm>
-            <a:off x="807164" y="1431693"/>
-            <a:ext cx="4275138" cy="477520"/>
-          </a:xfrm>
-        </p:spPr>
-        <p:txBody>
-          <a:bodyPr/>
-          <a:lstStyle/>
-          <a:p/>
-        </p:txBody>
-      </p:sp>
-      <p:pic>
-        <p:nvPicPr>
-          <p:cNvPr id="31" name="Picture 30" descr="fig07_disease_pest_risk_by_season.png"/>
           <p:cNvPicPr>
             <a:picLocks noChangeAspect="1"/>
           </p:cNvPicPr>
@@ -22442,8 +22589,8 @@
         </p:blipFill>
         <p:spPr>
           <a:xfrm>
-            <a:off x="731520" y="1554480"/>
-            <a:ext cx="6583680" cy="2351314"/>
+            <a:off x="830228" y="1275371"/>
+            <a:ext cx="8123624" cy="3238781"/>
           </a:xfrm>
           <a:prstGeom prst="rect">
             <a:avLst/>
@@ -22452,14 +22599,20 @@
       </p:pic>
       <p:sp>
         <p:nvSpPr>
-          <p:cNvPr id="32" name="TextBox 31"/>
+          <p:cNvPr id="12" name="TextBox 11">
+            <a:extLst>
+              <a:ext uri="{FF2B5EF4-FFF2-40B4-BE49-F238E27FC236}">
+                <a16:creationId xmlns:a16="http://schemas.microsoft.com/office/drawing/2014/main" id="{30D68974-92F4-EA2D-71DF-7C3855714A2D}"/>
+              </a:ext>
+            </a:extLst>
+          </p:cNvPr>
           <p:cNvSpPr txBox="1"/>
           <p:nvPr/>
         </p:nvSpPr>
         <p:spPr>
           <a:xfrm>
-            <a:off x="7498079" y="1645920"/>
-            <a:ext cx="4114800" cy="4114800"/>
+            <a:off x="213360" y="4682467"/>
+            <a:ext cx="12100559" cy="2031325"/>
           </a:xfrm>
           <a:prstGeom prst="rect">
             <a:avLst/>
@@ -22467,84 +22620,61 @@
           <a:noFill/>
         </p:spPr>
         <p:txBody>
-          <a:bodyPr wrap="square">
+          <a:bodyPr wrap="square" rtlCol="0">
             <a:spAutoFit/>
           </a:bodyPr>
           <a:lstStyle/>
           <a:p>
-            <a:pPr>
-              <a:defRPr sz="1250">
-                <a:solidFill>
-                  <a:srgbClr val="475569"/>
-                </a:solidFill>
-              </a:defRPr>
-            </a:pPr>
+            <a:pPr lvl="0"/>
             <a:r>
-              <a:t>Key Takeaways &amp; Findings:</a:t>
+              <a:rPr lang="en-IN" b="1" dirty="0"/>
+              <a:t>Micro-Irrigation Superiority:</a:t>
             </a:r>
-          </a:p>
-          <a:p>
-            <a:pPr>
-              <a:defRPr sz="1250">
-                <a:solidFill>
-                  <a:srgbClr val="475569"/>
-                </a:solidFill>
-              </a:defRPr>
-            </a:pPr>
-          </a:p>
-          <a:p>
-            <a:pPr>
-              <a:defRPr sz="1250">
-                <a:solidFill>
-                  <a:srgbClr val="475569"/>
-                </a:solidFill>
-              </a:defRPr>
-            </a:pPr>
             <a:r>
-              <a:t>â€¢ Monsoon Pest Surge: Kharif disease and pest risk averages 52.88%, compared to 38.89% in Rabi and 36.63% in Zaid.</a:t>
+              <a:rPr lang="en-IN" dirty="0"/>
+              <a:t> Drip irrigation delivers the highest water efficiency (</a:t>
             </a:r>
-          </a:p>
-          <a:p>
-            <a:pPr>
-              <a:defRPr sz="1250">
-                <a:solidFill>
-                  <a:srgbClr val="475569"/>
-                </a:solidFill>
-              </a:defRPr>
-            </a:pPr>
-          </a:p>
-          <a:p>
-            <a:pPr>
-              <a:defRPr sz="1250">
-                <a:solidFill>
-                  <a:srgbClr val="475569"/>
-                </a:solidFill>
-              </a:defRPr>
-            </a:pPr>
             <a:r>
-              <a:t>â€¢ High Effect Size: One-Way ANOVA proves this disparity is extraordinary (F = 1049.47, p &lt; 10^-300, Î·Â² = 0.3443).</a:t>
+              <a:rPr lang="en-IN" b="1" dirty="0"/>
+              <a:t>4.82 tonnes / 1000 m³</a:t>
             </a:r>
-          </a:p>
-          <a:p>
-            <a:pPr>
-              <a:defRPr sz="1250">
-                <a:solidFill>
-                  <a:srgbClr val="475569"/>
-                </a:solidFill>
-              </a:defRPr>
-            </a:pPr>
-          </a:p>
-          <a:p>
-            <a:pPr>
-              <a:defRPr sz="1250">
-                <a:solidFill>
-                  <a:srgbClr val="475569"/>
-                </a:solidFill>
-              </a:defRPr>
-            </a:pPr>
             <a:r>
-              <a:t>â€¢ Moisture-Infestation Link: Strong linear correlation between atmospheric humidity (&gt;70%) and pest risk drives a 25% surge in pesticide expenditure.</a:t>
+              <a:rPr lang="en-IN" dirty="0"/>
+              <a:t>), outperforming flood irrigation by </a:t>
             </a:r>
+            <a:r>
+              <a:rPr lang="en-IN" b="1" dirty="0"/>
+              <a:t>42%</a:t>
+            </a:r>
+            <a:r>
+              <a:rPr lang="en-IN" dirty="0"/>
+              <a:t>.</a:t>
+            </a:r>
+          </a:p>
+          <a:p>
+            <a:pPr lvl="0"/>
+            <a:r>
+              <a:rPr lang="en-IN" b="1" dirty="0"/>
+              <a:t>Flood Irrigation Inefficiency:</a:t>
+            </a:r>
+            <a:r>
+              <a:rPr lang="en-IN" dirty="0"/>
+              <a:t> Consumes &gt;9,000 m³ water on average, causing higher energy/pumping costs without proportionate yield gain.</a:t>
+            </a:r>
+          </a:p>
+          <a:p>
+            <a:pPr lvl="0"/>
+            <a:r>
+              <a:rPr lang="en-IN" b="1" dirty="0"/>
+              <a:t>Summer Optimization:</a:t>
+            </a:r>
+            <a:r>
+              <a:rPr lang="en-IN" dirty="0"/>
+              <a:t> Drip and sprinkler systems demonstrate maximum profit returns during water-scarce Zaid conditions.</a:t>
+            </a:r>
+          </a:p>
+          <a:p>
+            <a:endParaRPr lang="en-IN" dirty="0"/>
           </a:p>
         </p:txBody>
       </p:sp>
@@ -22873,121 +23003,6 @@
                       </p:childTnLst>
                     </p:cTn>
                   </p:par>
-                  <p:par>
-                    <p:cTn id="24" fill="hold">
-                      <p:stCondLst>
-                        <p:cond delay="indefinite"/>
-                      </p:stCondLst>
-                      <p:childTnLst>
-                        <p:par>
-                          <p:cTn id="25" fill="hold">
-                            <p:stCondLst>
-                              <p:cond delay="0"/>
-                            </p:stCondLst>
-                            <p:childTnLst>
-                              <p:par>
-                                <p:cTn id="26" presetID="42" presetClass="entr" presetSubtype="0" fill="hold" grpId="0" nodeType="clickEffect">
-                                  <p:stCondLst>
-                                    <p:cond delay="0"/>
-                                  </p:stCondLst>
-                                  <p:childTnLst>
-                                    <p:set>
-                                      <p:cBhvr>
-                                        <p:cTn id="27" dur="1" fill="hold">
-                                          <p:stCondLst>
-                                            <p:cond delay="0"/>
-                                          </p:stCondLst>
-                                        </p:cTn>
-                                        <p:tgtEl>
-                                          <p:spTgt spid="10">
-                                            <p:txEl>
-                                              <p:pRg st="0" end="0"/>
-                                            </p:txEl>
-                                          </p:spTgt>
-                                        </p:tgtEl>
-                                        <p:attrNameLst>
-                                          <p:attrName>style.visibility</p:attrName>
-                                        </p:attrNameLst>
-                                      </p:cBhvr>
-                                      <p:to>
-                                        <p:strVal val="visible"/>
-                                      </p:to>
-                                    </p:set>
-                                    <p:animEffect transition="in" filter="fade">
-                                      <p:cBhvr>
-                                        <p:cTn id="28" dur="1000"/>
-                                        <p:tgtEl>
-                                          <p:spTgt spid="10">
-                                            <p:txEl>
-                                              <p:pRg st="0" end="0"/>
-                                            </p:txEl>
-                                          </p:spTgt>
-                                        </p:tgtEl>
-                                      </p:cBhvr>
-                                    </p:animEffect>
-                                    <p:anim calcmode="lin" valueType="num">
-                                      <p:cBhvr>
-                                        <p:cTn id="29" dur="1000" fill="hold"/>
-                                        <p:tgtEl>
-                                          <p:spTgt spid="10">
-                                            <p:txEl>
-                                              <p:pRg st="0" end="0"/>
-                                            </p:txEl>
-                                          </p:spTgt>
-                                        </p:tgtEl>
-                                        <p:attrNameLst>
-                                          <p:attrName>ppt_x</p:attrName>
-                                        </p:attrNameLst>
-                                      </p:cBhvr>
-                                      <p:tavLst>
-                                        <p:tav tm="0">
-                                          <p:val>
-                                            <p:strVal val="#ppt_x"/>
-                                          </p:val>
-                                        </p:tav>
-                                        <p:tav tm="100000">
-                                          <p:val>
-                                            <p:strVal val="#ppt_x"/>
-                                          </p:val>
-                                        </p:tav>
-                                      </p:tavLst>
-                                    </p:anim>
-                                    <p:anim calcmode="lin" valueType="num">
-                                      <p:cBhvr>
-                                        <p:cTn id="30" dur="1000" fill="hold"/>
-                                        <p:tgtEl>
-                                          <p:spTgt spid="10">
-                                            <p:txEl>
-                                              <p:pRg st="0" end="0"/>
-                                            </p:txEl>
-                                          </p:spTgt>
-                                        </p:tgtEl>
-                                        <p:attrNameLst>
-                                          <p:attrName>ppt_y</p:attrName>
-                                        </p:attrNameLst>
-                                      </p:cBhvr>
-                                      <p:tavLst>
-                                        <p:tav tm="0">
-                                          <p:val>
-                                            <p:strVal val="#ppt_y+.1"/>
-                                          </p:val>
-                                        </p:tav>
-                                        <p:tav tm="100000">
-                                          <p:val>
-                                            <p:strVal val="#ppt_y"/>
-                                          </p:val>
-                                        </p:tav>
-                                      </p:tavLst>
-                                    </p:anim>
-                                  </p:childTnLst>
-                                </p:cTn>
-                              </p:par>
-                            </p:childTnLst>
-                          </p:cTn>
-                        </p:par>
-                      </p:childTnLst>
-                    </p:cTn>
-                  </p:par>
                 </p:childTnLst>
               </p:cTn>
               <p:prevCondLst>
@@ -23013,7 +23028,6 @@
       <p:bldP spid="4" grpId="0"/>
       <p:bldP spid="7" grpId="0"/>
       <p:bldP spid="8" grpId="0"/>
-      <p:bldP spid="10" grpId="0" build="p"/>
     </p:bldLst>
   </p:timing>
 </p:sld>
@@ -23099,16 +23113,11 @@
           </a:bodyPr>
           <a:lstStyle/>
           <a:p>
-            <a:pPr>
-              <a:defRPr b="1" sz="2200">
-                <a:solidFill>
-                  <a:srgbClr val="0F172A"/>
-                </a:solidFill>
-              </a:defRPr>
-            </a:pPr>
             <a:r>
-              <a:t>RESULTS: Irrigation Method Effectiveness Across Seasons</a:t>
+              <a:rPr lang="en-GB" dirty="0"/>
+              <a:t>RESULTS </a:t>
             </a:r>
+            <a:endParaRPr lang="en-IN" dirty="0"/>
           </a:p>
         </p:txBody>
       </p:sp>
@@ -23624,37 +23633,15 @@
           </a:p>
         </p:txBody>
       </p:sp>
-      <p:sp>
-        <p:nvSpPr>
-          <p:cNvPr id="10" name="Text Placeholder 1">
+      <p:pic>
+        <p:nvPicPr>
+          <p:cNvPr id="3" name="Picture 2" descr="fig12_statistical_tests_summary_table.png">
             <a:extLst>
               <a:ext uri="{FF2B5EF4-FFF2-40B4-BE49-F238E27FC236}">
-                <a16:creationId xmlns:a16="http://schemas.microsoft.com/office/drawing/2014/main" id="{2B7B89A1-9444-8322-CADC-42D31D698FA8}"/>
+                <a16:creationId xmlns:a16="http://schemas.microsoft.com/office/drawing/2014/main" id="{DC5F6E67-7AB8-2D18-CA8D-8202F40902C3}"/>
               </a:ext>
             </a:extLst>
           </p:cNvPr>
-          <p:cNvSpPr>
-            <a:spLocks noGrp="1"/>
-          </p:cNvSpPr>
-          <p:nvPr>
-            <p:ph type="body" sz="quarter" idx="12"/>
-          </p:nvPr>
-        </p:nvSpPr>
-        <p:spPr>
-          <a:xfrm>
-            <a:off x="807164" y="1431693"/>
-            <a:ext cx="4275138" cy="477520"/>
-          </a:xfrm>
-        </p:spPr>
-        <p:txBody>
-          <a:bodyPr/>
-          <a:lstStyle/>
-          <a:p/>
-        </p:txBody>
-      </p:sp>
-      <p:pic>
-        <p:nvPicPr>
-          <p:cNvPr id="31" name="Picture 30" descr="fig06_water_efficiency_irrigation_heatmap.png"/>
           <p:cNvPicPr>
             <a:picLocks noChangeAspect="1"/>
           </p:cNvPicPr>
@@ -23668,112 +23655,14 @@
         </p:blipFill>
         <p:spPr>
           <a:xfrm>
-            <a:off x="731520" y="1554480"/>
-            <a:ext cx="6583680" cy="2414016"/>
+            <a:off x="731520" y="1463040"/>
+            <a:ext cx="10805160" cy="4853354"/>
           </a:xfrm>
           <a:prstGeom prst="rect">
             <a:avLst/>
           </a:prstGeom>
         </p:spPr>
       </p:pic>
-      <p:sp>
-        <p:nvSpPr>
-          <p:cNvPr id="32" name="TextBox 31"/>
-          <p:cNvSpPr txBox="1"/>
-          <p:nvPr/>
-        </p:nvSpPr>
-        <p:spPr>
-          <a:xfrm>
-            <a:off x="7498079" y="1645920"/>
-            <a:ext cx="4114800" cy="4114800"/>
-          </a:xfrm>
-          <a:prstGeom prst="rect">
-            <a:avLst/>
-          </a:prstGeom>
-          <a:noFill/>
-        </p:spPr>
-        <p:txBody>
-          <a:bodyPr wrap="square">
-            <a:spAutoFit/>
-          </a:bodyPr>
-          <a:lstStyle/>
-          <a:p>
-            <a:pPr>
-              <a:defRPr sz="1250">
-                <a:solidFill>
-                  <a:srgbClr val="475569"/>
-                </a:solidFill>
-              </a:defRPr>
-            </a:pPr>
-            <a:r>
-              <a:t>Key Takeaways &amp; Findings:</a:t>
-            </a:r>
-          </a:p>
-          <a:p>
-            <a:pPr>
-              <a:defRPr sz="1250">
-                <a:solidFill>
-                  <a:srgbClr val="475569"/>
-                </a:solidFill>
-              </a:defRPr>
-            </a:pPr>
-          </a:p>
-          <a:p>
-            <a:pPr>
-              <a:defRPr sz="1250">
-                <a:solidFill>
-                  <a:srgbClr val="475569"/>
-                </a:solidFill>
-              </a:defRPr>
-            </a:pPr>
-            <a:r>
-              <a:t>â€¢ Micro-Irrigation Superiority: Drip irrigation achieves 4.82 t/1000mÂ³ water efficiency, beating Flood systems (1.64 t/1000mÂ³) by nearly 3x.</a:t>
-            </a:r>
-          </a:p>
-          <a:p>
-            <a:pPr>
-              <a:defRPr sz="1250">
-                <a:solidFill>
-                  <a:srgbClr val="475569"/>
-                </a:solidFill>
-              </a:defRPr>
-            </a:pPr>
-          </a:p>
-          <a:p>
-            <a:pPr>
-              <a:defRPr sz="1250">
-                <a:solidFill>
-                  <a:srgbClr val="475569"/>
-                </a:solidFill>
-              </a:defRPr>
-            </a:pPr>
-            <a:r>
-              <a:t>â€¢ Flood Inefficiency: Flood irrigation consumes &gt;9,000 mÂ³ of water on average, elevating pumping electricity and extraction costs.</a:t>
-            </a:r>
-          </a:p>
-          <a:p>
-            <a:pPr>
-              <a:defRPr sz="1250">
-                <a:solidFill>
-                  <a:srgbClr val="475569"/>
-                </a:solidFill>
-              </a:defRPr>
-            </a:pPr>
-          </a:p>
-          <a:p>
-            <a:pPr>
-              <a:defRPr sz="1250">
-                <a:solidFill>
-                  <a:srgbClr val="475569"/>
-                </a:solidFill>
-              </a:defRPr>
-            </a:pPr>
-            <a:r>
-              <a:t>â€¢ Summer Water Optimization: Zaid micro-irrigation maximizes yield per unit water applied during peak evaporation conditions.</a:t>
-            </a:r>
-          </a:p>
-        </p:txBody>
-      </p:sp>
     </p:spTree>
     <p:extLst>
       <p:ext uri="{BB962C8B-B14F-4D97-AF65-F5344CB8AC3E}">
@@ -24099,121 +23988,6 @@
                       </p:childTnLst>
                     </p:cTn>
                   </p:par>
-                  <p:par>
-                    <p:cTn id="24" fill="hold">
-                      <p:stCondLst>
-                        <p:cond delay="indefinite"/>
-                      </p:stCondLst>
-                      <p:childTnLst>
-                        <p:par>
-                          <p:cTn id="25" fill="hold">
-                            <p:stCondLst>
-                              <p:cond delay="0"/>
-                            </p:stCondLst>
-                            <p:childTnLst>
-                              <p:par>
-                                <p:cTn id="26" presetID="42" presetClass="entr" presetSubtype="0" fill="hold" grpId="0" nodeType="clickEffect">
-                                  <p:stCondLst>
-                                    <p:cond delay="0"/>
-                                  </p:stCondLst>
-                                  <p:childTnLst>
-                                    <p:set>
-                                      <p:cBhvr>
-                                        <p:cTn id="27" dur="1" fill="hold">
-                                          <p:stCondLst>
-                                            <p:cond delay="0"/>
-                                          </p:stCondLst>
-                                        </p:cTn>
-                                        <p:tgtEl>
-                                          <p:spTgt spid="10">
-                                            <p:txEl>
-                                              <p:pRg st="0" end="0"/>
-                                            </p:txEl>
-                                          </p:spTgt>
-                                        </p:tgtEl>
-                                        <p:attrNameLst>
-                                          <p:attrName>style.visibility</p:attrName>
-                                        </p:attrNameLst>
-                                      </p:cBhvr>
-                                      <p:to>
-                                        <p:strVal val="visible"/>
-                                      </p:to>
-                                    </p:set>
-                                    <p:animEffect transition="in" filter="fade">
-                                      <p:cBhvr>
-                                        <p:cTn id="28" dur="1000"/>
-                                        <p:tgtEl>
-                                          <p:spTgt spid="10">
-                                            <p:txEl>
-                                              <p:pRg st="0" end="0"/>
-                                            </p:txEl>
-                                          </p:spTgt>
-                                        </p:tgtEl>
-                                      </p:cBhvr>
-                                    </p:animEffect>
-                                    <p:anim calcmode="lin" valueType="num">
-                                      <p:cBhvr>
-                                        <p:cTn id="29" dur="1000" fill="hold"/>
-                                        <p:tgtEl>
-                                          <p:spTgt spid="10">
-                                            <p:txEl>
-                                              <p:pRg st="0" end="0"/>
-                                            </p:txEl>
-                                          </p:spTgt>
-                                        </p:tgtEl>
-                                        <p:attrNameLst>
-                                          <p:attrName>ppt_x</p:attrName>
-                                        </p:attrNameLst>
-                                      </p:cBhvr>
-                                      <p:tavLst>
-                                        <p:tav tm="0">
-                                          <p:val>
-                                            <p:strVal val="#ppt_x"/>
-                                          </p:val>
-                                        </p:tav>
-                                        <p:tav tm="100000">
-                                          <p:val>
-                                            <p:strVal val="#ppt_x"/>
-                                          </p:val>
-                                        </p:tav>
-                                      </p:tavLst>
-                                    </p:anim>
-                                    <p:anim calcmode="lin" valueType="num">
-                                      <p:cBhvr>
-                                        <p:cTn id="30" dur="1000" fill="hold"/>
-                                        <p:tgtEl>
-                                          <p:spTgt spid="10">
-                                            <p:txEl>
-                                              <p:pRg st="0" end="0"/>
-                                            </p:txEl>
-                                          </p:spTgt>
-                                        </p:tgtEl>
-                                        <p:attrNameLst>
-                                          <p:attrName>ppt_y</p:attrName>
-                                        </p:attrNameLst>
-                                      </p:cBhvr>
-                                      <p:tavLst>
-                                        <p:tav tm="0">
-                                          <p:val>
-                                            <p:strVal val="#ppt_y+.1"/>
-                                          </p:val>
-                                        </p:tav>
-                                        <p:tav tm="100000">
-                                          <p:val>
-                                            <p:strVal val="#ppt_y"/>
-                                          </p:val>
-                                        </p:tav>
-                                      </p:tavLst>
-                                    </p:anim>
-                                  </p:childTnLst>
-                                </p:cTn>
-                              </p:par>
-                            </p:childTnLst>
-                          </p:cTn>
-                        </p:par>
-                      </p:childTnLst>
-                    </p:cTn>
-                  </p:par>
                 </p:childTnLst>
               </p:cTn>
               <p:prevCondLst>
@@ -24239,7 +24013,6 @@
       <p:bldP spid="4" grpId="0"/>
       <p:bldP spid="7" grpId="0"/>
       <p:bldP spid="8" grpId="0"/>
-      <p:bldP spid="10" grpId="0" build="p"/>
     </p:bldLst>
   </p:timing>
 </p:sld>

</xml_diff>